<commit_message>
Remove the confidential footer line from every slide in the v5 deck.
Co-authored-by: lysakalenushka-hash <lysakalenushka-hash@users.noreply.github.com>
</commit_message>
<xml_diff>
--- a/issledovaniya/Lab-Intellekt_prodayushchaya-prezentaciya_v5.pptx
+++ b/issledovaniya/Lab-Intellekt_prodayushchaya-prezentaciya_v5.pptx
@@ -4199,43 +4199,6 @@
       </p:sp>
       <p:sp>
         <p:nvSpPr>
-          <p:cNvPr id="7" name="TextBox 6"/>
-          <p:cNvSpPr txBox="1"/>
-          <p:nvPr/>
-        </p:nvSpPr>
-        <p:spPr>
-          <a:xfrm>
-            <a:off x="457200" y="6565392"/>
-            <a:ext cx="8229600" cy="256032"/>
-          </a:xfrm>
-          <a:prstGeom prst="rect">
-            <a:avLst/>
-          </a:prstGeom>
-          <a:noFill/>
-        </p:spPr>
-        <p:txBody>
-          <a:bodyPr wrap="none">
-            <a:spAutoFit/>
-          </a:bodyPr>
-          <a:lstStyle/>
-          <a:p>
-            <a:pPr algn="l"/>
-            <a:r>
-              <a:rPr sz="1100" b="0" i="0">
-                <a:solidFill>
-                  <a:srgbClr val="8AA0B8"/>
-                </a:solidFill>
-                <a:latin typeface="Calibri"/>
-                <a:ea typeface="Calibri"/>
-                <a:cs typeface="Calibri"/>
-              </a:rPr>
-              <a:t>Lab-Интеллект  ·  СМАРТА  ·  конфиденциально</a:t>
-            </a:r>
-          </a:p>
-        </p:txBody>
-      </p:sp>
-      <p:sp>
-        <p:nvSpPr>
           <p:cNvPr id="8" name="TextBox 7"/>
           <p:cNvSpPr txBox="1"/>
           <p:nvPr/>
@@ -5069,43 +5032,6 @@
           </a:prstGeom>
         </p:spPr>
       </p:pic>
-      <p:sp>
-        <p:nvSpPr>
-          <p:cNvPr id="22" name="TextBox 21"/>
-          <p:cNvSpPr txBox="1"/>
-          <p:nvPr/>
-        </p:nvSpPr>
-        <p:spPr>
-          <a:xfrm>
-            <a:off x="457200" y="6565392"/>
-            <a:ext cx="8229600" cy="256032"/>
-          </a:xfrm>
-          <a:prstGeom prst="rect">
-            <a:avLst/>
-          </a:prstGeom>
-          <a:noFill/>
-        </p:spPr>
-        <p:txBody>
-          <a:bodyPr wrap="square" anchor="ctr">
-            <a:spAutoFit/>
-          </a:bodyPr>
-          <a:lstStyle/>
-          <a:p>
-            <a:pPr algn="l"/>
-            <a:r>
-              <a:rPr sz="1100" b="0" i="0">
-                <a:solidFill>
-                  <a:srgbClr val="9AA3B0"/>
-                </a:solidFill>
-                <a:latin typeface="Calibri"/>
-                <a:ea typeface="Calibri"/>
-                <a:cs typeface="Calibri"/>
-              </a:rPr>
-              <a:t>Lab-Интеллект  ·  СМАРТА  ·  конфиденциально</a:t>
-            </a:r>
-          </a:p>
-        </p:txBody>
-      </p:sp>
       <p:sp>
         <p:nvSpPr>
           <p:cNvPr id="23" name="TextBox 22"/>
@@ -6435,43 +6361,6 @@
           </a:p>
         </p:txBody>
       </p:sp>
-      <p:sp>
-        <p:nvSpPr>
-          <p:cNvPr id="10" name="TextBox 9"/>
-          <p:cNvSpPr txBox="1"/>
-          <p:nvPr/>
-        </p:nvSpPr>
-        <p:spPr>
-          <a:xfrm>
-            <a:off x="457200" y="6565392"/>
-            <a:ext cx="8229600" cy="256032"/>
-          </a:xfrm>
-          <a:prstGeom prst="rect">
-            <a:avLst/>
-          </a:prstGeom>
-          <a:noFill/>
-        </p:spPr>
-        <p:txBody>
-          <a:bodyPr wrap="none">
-            <a:spAutoFit/>
-          </a:bodyPr>
-          <a:lstStyle/>
-          <a:p>
-            <a:pPr algn="l"/>
-            <a:r>
-              <a:rPr sz="1100" b="0" i="0">
-                <a:solidFill>
-                  <a:srgbClr val="9AA3B0"/>
-                </a:solidFill>
-                <a:latin typeface="Calibri"/>
-                <a:ea typeface="Calibri"/>
-                <a:cs typeface="Calibri"/>
-              </a:rPr>
-              <a:t>Lab-Интеллект  ·  СМАРТА  ·  конфиденциально</a:t>
-            </a:r>
-          </a:p>
-        </p:txBody>
-      </p:sp>
     </p:spTree>
   </p:cSld>
   <p:clrMapOvr>
@@ -6894,43 +6783,6 @@
       </p:sp>
       <p:sp>
         <p:nvSpPr>
-          <p:cNvPr id="7" name="TextBox 6"/>
-          <p:cNvSpPr txBox="1"/>
-          <p:nvPr/>
-        </p:nvSpPr>
-        <p:spPr>
-          <a:xfrm>
-            <a:off x="457200" y="6565392"/>
-            <a:ext cx="8229600" cy="256032"/>
-          </a:xfrm>
-          <a:prstGeom prst="rect">
-            <a:avLst/>
-          </a:prstGeom>
-          <a:noFill/>
-        </p:spPr>
-        <p:txBody>
-          <a:bodyPr wrap="none">
-            <a:spAutoFit/>
-          </a:bodyPr>
-          <a:lstStyle/>
-          <a:p>
-            <a:pPr algn="l"/>
-            <a:r>
-              <a:rPr sz="1100" b="0" i="0">
-                <a:solidFill>
-                  <a:srgbClr val="8AA0B8"/>
-                </a:solidFill>
-                <a:latin typeface="Calibri"/>
-                <a:ea typeface="Calibri"/>
-                <a:cs typeface="Calibri"/>
-              </a:rPr>
-              <a:t>Lab-Интеллект  ·  СМАРТА  ·  конфиденциально</a:t>
-            </a:r>
-          </a:p>
-        </p:txBody>
-      </p:sp>
-      <p:sp>
-        <p:nvSpPr>
           <p:cNvPr id="8" name="TextBox 7"/>
           <p:cNvSpPr txBox="1"/>
           <p:nvPr/>
@@ -7687,43 +7539,6 @@
           </a:p>
         </p:txBody>
       </p:sp>
-      <p:sp>
-        <p:nvSpPr>
-          <p:cNvPr id="21" name="TextBox 20"/>
-          <p:cNvSpPr txBox="1"/>
-          <p:nvPr/>
-        </p:nvSpPr>
-        <p:spPr>
-          <a:xfrm>
-            <a:off x="457200" y="6565392"/>
-            <a:ext cx="8229600" cy="256032"/>
-          </a:xfrm>
-          <a:prstGeom prst="rect">
-            <a:avLst/>
-          </a:prstGeom>
-          <a:noFill/>
-        </p:spPr>
-        <p:txBody>
-          <a:bodyPr wrap="none">
-            <a:spAutoFit/>
-          </a:bodyPr>
-          <a:lstStyle/>
-          <a:p>
-            <a:pPr algn="l"/>
-            <a:r>
-              <a:rPr sz="1100" b="0" i="0">
-                <a:solidFill>
-                  <a:srgbClr val="9AA3B0"/>
-                </a:solidFill>
-                <a:latin typeface="Calibri"/>
-                <a:ea typeface="Calibri"/>
-                <a:cs typeface="Calibri"/>
-              </a:rPr>
-              <a:t>Lab-Интеллект  ·  СМАРТА  ·  конфиденциально</a:t>
-            </a:r>
-          </a:p>
-        </p:txBody>
-      </p:sp>
     </p:spTree>
   </p:cSld>
   <p:clrMapOvr>
@@ -8641,43 +8456,6 @@
           </a:p>
         </p:txBody>
       </p:sp>
-      <p:sp>
-        <p:nvSpPr>
-          <p:cNvPr id="22" name="TextBox 21"/>
-          <p:cNvSpPr txBox="1"/>
-          <p:nvPr/>
-        </p:nvSpPr>
-        <p:spPr>
-          <a:xfrm>
-            <a:off x="457200" y="6565392"/>
-            <a:ext cx="8229600" cy="256032"/>
-          </a:xfrm>
-          <a:prstGeom prst="rect">
-            <a:avLst/>
-          </a:prstGeom>
-          <a:noFill/>
-        </p:spPr>
-        <p:txBody>
-          <a:bodyPr wrap="none">
-            <a:spAutoFit/>
-          </a:bodyPr>
-          <a:lstStyle/>
-          <a:p>
-            <a:pPr algn="l"/>
-            <a:r>
-              <a:rPr sz="1100" b="0" i="0">
-                <a:solidFill>
-                  <a:srgbClr val="9AA3B0"/>
-                </a:solidFill>
-                <a:latin typeface="Calibri"/>
-                <a:ea typeface="Calibri"/>
-                <a:cs typeface="Calibri"/>
-              </a:rPr>
-              <a:t>Lab-Интеллект  ·  СМАРТА  ·  конфиденциально</a:t>
-            </a:r>
-          </a:p>
-        </p:txBody>
-      </p:sp>
     </p:spTree>
   </p:cSld>
   <p:clrMapOvr>
@@ -9442,41 +9220,6 @@
       </p:sp>
       <p:sp>
         <p:nvSpPr>
-          <p:cNvPr id="21" name="TextBox 20"/>
-          <p:cNvSpPr txBox="1"/>
-          <p:nvPr/>
-        </p:nvSpPr>
-        <p:spPr>
-          <a:xfrm>
-            <a:off x="457200" y="6565392"/>
-            <a:ext cx="8229600" cy="256032"/>
-          </a:xfrm>
-          <a:prstGeom prst="rect">
-            <a:avLst/>
-          </a:prstGeom>
-          <a:noFill/>
-        </p:spPr>
-        <p:txBody>
-          <a:bodyPr wrap="square" anchor="t"/>
-          <a:lstStyle/>
-          <a:p>
-            <a:pPr algn="l"/>
-            <a:r>
-              <a:rPr sz="1100" b="0" i="0">
-                <a:solidFill>
-                  <a:srgbClr val="9AA3B0"/>
-                </a:solidFill>
-                <a:latin typeface="Calibri"/>
-                <a:ea typeface="Calibri"/>
-                <a:cs typeface="Calibri"/>
-              </a:rPr>
-              <a:t>Lab-Интеллект  ·  СМАРТА  ·  конфиденциально</a:t>
-            </a:r>
-          </a:p>
-        </p:txBody>
-      </p:sp>
-      <p:sp>
-        <p:nvSpPr>
           <p:cNvPr id="22" name="TextBox 21"/>
           <p:cNvSpPr txBox="1"/>
           <p:nvPr/>
@@ -9736,41 +9479,6 @@
                 <a:cs typeface="Calibri"/>
               </a:rPr>
               <a:t>Польза для работника, куратора, специалиста по ОТ и руководителя</a:t>
-            </a:r>
-          </a:p>
-        </p:txBody>
-      </p:sp>
-      <p:sp>
-        <p:nvSpPr>
-          <p:cNvPr id="8" name="TextBox 7"/>
-          <p:cNvSpPr txBox="1"/>
-          <p:nvPr/>
-        </p:nvSpPr>
-        <p:spPr>
-          <a:xfrm>
-            <a:off x="457200" y="6565392"/>
-            <a:ext cx="8229600" cy="256032"/>
-          </a:xfrm>
-          <a:prstGeom prst="rect">
-            <a:avLst/>
-          </a:prstGeom>
-          <a:noFill/>
-        </p:spPr>
-        <p:txBody>
-          <a:bodyPr wrap="square" anchor="t"/>
-          <a:lstStyle/>
-          <a:p>
-            <a:pPr algn="l"/>
-            <a:r>
-              <a:rPr sz="1100" b="0" i="0">
-                <a:solidFill>
-                  <a:srgbClr val="9AA3B0"/>
-                </a:solidFill>
-                <a:latin typeface="Calibri"/>
-                <a:ea typeface="Calibri"/>
-                <a:cs typeface="Calibri"/>
-              </a:rPr>
-              <a:t>Lab-Интеллект  ·  СМАРТА  ·  конфиденциально</a:t>
             </a:r>
           </a:p>
         </p:txBody>
@@ -11757,43 +11465,6 @@
           </a:p>
         </p:txBody>
       </p:sp>
-      <p:sp>
-        <p:nvSpPr>
-          <p:cNvPr id="22" name="TextBox 21"/>
-          <p:cNvSpPr txBox="1"/>
-          <p:nvPr/>
-        </p:nvSpPr>
-        <p:spPr>
-          <a:xfrm>
-            <a:off x="457200" y="6565392"/>
-            <a:ext cx="8229600" cy="256032"/>
-          </a:xfrm>
-          <a:prstGeom prst="rect">
-            <a:avLst/>
-          </a:prstGeom>
-          <a:noFill/>
-        </p:spPr>
-        <p:txBody>
-          <a:bodyPr wrap="none">
-            <a:spAutoFit/>
-          </a:bodyPr>
-          <a:lstStyle/>
-          <a:p>
-            <a:pPr algn="l"/>
-            <a:r>
-              <a:rPr sz="1100" b="0" i="0">
-                <a:solidFill>
-                  <a:srgbClr val="9AA3B0"/>
-                </a:solidFill>
-                <a:latin typeface="Calibri"/>
-                <a:ea typeface="Calibri"/>
-                <a:cs typeface="Calibri"/>
-              </a:rPr>
-              <a:t>Lab-Интеллект  ·  СМАРТА  ·  конфиденциально</a:t>
-            </a:r>
-          </a:p>
-        </p:txBody>
-      </p:sp>
     </p:spTree>
   </p:cSld>
   <p:clrMapOvr>
@@ -12739,43 +12410,6 @@
           </a:p>
         </p:txBody>
       </p:sp>
-      <p:sp>
-        <p:nvSpPr>
-          <p:cNvPr id="15" name="TextBox 14"/>
-          <p:cNvSpPr txBox="1"/>
-          <p:nvPr/>
-        </p:nvSpPr>
-        <p:spPr>
-          <a:xfrm>
-            <a:off x="457200" y="6565392"/>
-            <a:ext cx="8229600" cy="256032"/>
-          </a:xfrm>
-          <a:prstGeom prst="rect">
-            <a:avLst/>
-          </a:prstGeom>
-          <a:noFill/>
-        </p:spPr>
-        <p:txBody>
-          <a:bodyPr wrap="none">
-            <a:spAutoFit/>
-          </a:bodyPr>
-          <a:lstStyle/>
-          <a:p>
-            <a:pPr algn="l"/>
-            <a:r>
-              <a:rPr sz="1100" b="0" i="0">
-                <a:solidFill>
-                  <a:srgbClr val="9AA3B0"/>
-                </a:solidFill>
-                <a:latin typeface="Calibri"/>
-                <a:ea typeface="Calibri"/>
-                <a:cs typeface="Calibri"/>
-              </a:rPr>
-              <a:t>Lab-Интеллект  ·  СМАРТА  ·  конфиденциально</a:t>
-            </a:r>
-          </a:p>
-        </p:txBody>
-      </p:sp>
     </p:spTree>
   </p:cSld>
   <p:clrMapOvr>
@@ -13682,43 +13316,6 @@
           </a:p>
         </p:txBody>
       </p:sp>
-      <p:sp>
-        <p:nvSpPr>
-          <p:cNvPr id="22" name="TextBox 21"/>
-          <p:cNvSpPr txBox="1"/>
-          <p:nvPr/>
-        </p:nvSpPr>
-        <p:spPr>
-          <a:xfrm>
-            <a:off x="457200" y="6565392"/>
-            <a:ext cx="8229600" cy="256032"/>
-          </a:xfrm>
-          <a:prstGeom prst="rect">
-            <a:avLst/>
-          </a:prstGeom>
-          <a:noFill/>
-        </p:spPr>
-        <p:txBody>
-          <a:bodyPr wrap="none">
-            <a:spAutoFit/>
-          </a:bodyPr>
-          <a:lstStyle/>
-          <a:p>
-            <a:pPr algn="l"/>
-            <a:r>
-              <a:rPr sz="1100" b="0" i="0">
-                <a:solidFill>
-                  <a:srgbClr val="9AA3B0"/>
-                </a:solidFill>
-                <a:latin typeface="Calibri"/>
-                <a:ea typeface="Calibri"/>
-                <a:cs typeface="Calibri"/>
-              </a:rPr>
-              <a:t>Lab-Интеллект  ·  СМАРТА  ·  конфиденциально</a:t>
-            </a:r>
-          </a:p>
-        </p:txBody>
-      </p:sp>
     </p:spTree>
   </p:cSld>
   <p:clrMapOvr>
@@ -14967,43 +14564,6 @@
           </a:p>
         </p:txBody>
       </p:sp>
-      <p:sp>
-        <p:nvSpPr>
-          <p:cNvPr id="24" name="TextBox 23"/>
-          <p:cNvSpPr txBox="1"/>
-          <p:nvPr/>
-        </p:nvSpPr>
-        <p:spPr>
-          <a:xfrm>
-            <a:off x="457200" y="6565392"/>
-            <a:ext cx="8229600" cy="256032"/>
-          </a:xfrm>
-          <a:prstGeom prst="rect">
-            <a:avLst/>
-          </a:prstGeom>
-          <a:noFill/>
-        </p:spPr>
-        <p:txBody>
-          <a:bodyPr wrap="none">
-            <a:spAutoFit/>
-          </a:bodyPr>
-          <a:lstStyle/>
-          <a:p>
-            <a:pPr algn="l"/>
-            <a:r>
-              <a:rPr sz="1100" b="0" i="0">
-                <a:solidFill>
-                  <a:srgbClr val="9AA3B0"/>
-                </a:solidFill>
-                <a:latin typeface="Calibri"/>
-                <a:ea typeface="Calibri"/>
-                <a:cs typeface="Calibri"/>
-              </a:rPr>
-              <a:t>Lab-Интеллект  ·  СМАРТА  ·  конфиденциально</a:t>
-            </a:r>
-          </a:p>
-        </p:txBody>
-      </p:sp>
     </p:spTree>
   </p:cSld>
   <p:clrMapOvr>
@@ -16289,43 +15849,6 @@
           </a:p>
         </p:txBody>
       </p:sp>
-      <p:sp>
-        <p:nvSpPr>
-          <p:cNvPr id="21" name="TextBox 20"/>
-          <p:cNvSpPr txBox="1"/>
-          <p:nvPr/>
-        </p:nvSpPr>
-        <p:spPr>
-          <a:xfrm>
-            <a:off x="457200" y="6565392"/>
-            <a:ext cx="8229600" cy="256032"/>
-          </a:xfrm>
-          <a:prstGeom prst="rect">
-            <a:avLst/>
-          </a:prstGeom>
-          <a:noFill/>
-        </p:spPr>
-        <p:txBody>
-          <a:bodyPr wrap="none">
-            <a:spAutoFit/>
-          </a:bodyPr>
-          <a:lstStyle/>
-          <a:p>
-            <a:pPr algn="l"/>
-            <a:r>
-              <a:rPr sz="1100" b="0" i="0">
-                <a:solidFill>
-                  <a:srgbClr val="9AA3B0"/>
-                </a:solidFill>
-                <a:latin typeface="Calibri"/>
-                <a:ea typeface="Calibri"/>
-                <a:cs typeface="Calibri"/>
-              </a:rPr>
-              <a:t>Lab-Интеллект  ·  СМАРТА  ·  конфиденциально</a:t>
-            </a:r>
-          </a:p>
-        </p:txBody>
-      </p:sp>
     </p:spTree>
   </p:cSld>
   <p:clrMapOvr>
@@ -17751,43 +17274,6 @@
           </a:p>
         </p:txBody>
       </p:sp>
-      <p:sp>
-        <p:nvSpPr>
-          <p:cNvPr id="31" name="TextBox 30"/>
-          <p:cNvSpPr txBox="1"/>
-          <p:nvPr/>
-        </p:nvSpPr>
-        <p:spPr>
-          <a:xfrm>
-            <a:off x="457200" y="6565392"/>
-            <a:ext cx="8229600" cy="256032"/>
-          </a:xfrm>
-          <a:prstGeom prst="rect">
-            <a:avLst/>
-          </a:prstGeom>
-          <a:noFill/>
-        </p:spPr>
-        <p:txBody>
-          <a:bodyPr wrap="none">
-            <a:spAutoFit/>
-          </a:bodyPr>
-          <a:lstStyle/>
-          <a:p>
-            <a:pPr algn="l"/>
-            <a:r>
-              <a:rPr sz="1100" b="0" i="0">
-                <a:solidFill>
-                  <a:srgbClr val="9AA3B0"/>
-                </a:solidFill>
-                <a:latin typeface="Calibri"/>
-                <a:ea typeface="Calibri"/>
-                <a:cs typeface="Calibri"/>
-              </a:rPr>
-              <a:t>Lab-Интеллект  ·  СМАРТА  ·  конфиденциально</a:t>
-            </a:r>
-          </a:p>
-        </p:txBody>
-      </p:sp>
     </p:spTree>
   </p:cSld>
   <p:clrMapOvr>
@@ -18497,43 +17983,6 @@
           </a:p>
         </p:txBody>
       </p:sp>
-      <p:sp>
-        <p:nvSpPr>
-          <p:cNvPr id="15" name="TextBox 14"/>
-          <p:cNvSpPr txBox="1"/>
-          <p:nvPr/>
-        </p:nvSpPr>
-        <p:spPr>
-          <a:xfrm>
-            <a:off x="457200" y="6565392"/>
-            <a:ext cx="8229600" cy="256032"/>
-          </a:xfrm>
-          <a:prstGeom prst="rect">
-            <a:avLst/>
-          </a:prstGeom>
-          <a:noFill/>
-        </p:spPr>
-        <p:txBody>
-          <a:bodyPr wrap="none">
-            <a:spAutoFit/>
-          </a:bodyPr>
-          <a:lstStyle/>
-          <a:p>
-            <a:pPr algn="l"/>
-            <a:r>
-              <a:rPr sz="1100" b="0" i="0">
-                <a:solidFill>
-                  <a:srgbClr val="9AA3B0"/>
-                </a:solidFill>
-                <a:latin typeface="Calibri"/>
-                <a:ea typeface="Calibri"/>
-                <a:cs typeface="Calibri"/>
-              </a:rPr>
-              <a:t>Lab-Интеллект  ·  СМАРТА  ·  конфиденциально</a:t>
-            </a:r>
-          </a:p>
-        </p:txBody>
-      </p:sp>
     </p:spTree>
   </p:cSld>
   <p:clrMapOvr>
@@ -19522,43 +18971,6 @@
             <a:r>
               <a:rPr lang="ru-RU" dirty="0"/>
               <a:t>Этот слайд пока не делаем, здесь будет про методику оценки вовлеченности</a:t>
-            </a:r>
-          </a:p>
-        </p:txBody>
-      </p:sp>
-      <p:sp>
-        <p:nvSpPr>
-          <p:cNvPr id="26" name="TextBox 25"/>
-          <p:cNvSpPr txBox="1"/>
-          <p:nvPr/>
-        </p:nvSpPr>
-        <p:spPr>
-          <a:xfrm>
-            <a:off x="457200" y="6565392"/>
-            <a:ext cx="8229600" cy="256032"/>
-          </a:xfrm>
-          <a:prstGeom prst="rect">
-            <a:avLst/>
-          </a:prstGeom>
-          <a:noFill/>
-        </p:spPr>
-        <p:txBody>
-          <a:bodyPr wrap="none">
-            <a:spAutoFit/>
-          </a:bodyPr>
-          <a:lstStyle/>
-          <a:p>
-            <a:pPr algn="l"/>
-            <a:r>
-              <a:rPr sz="1100" b="0" i="0">
-                <a:solidFill>
-                  <a:srgbClr val="9AA3B0"/>
-                </a:solidFill>
-                <a:latin typeface="Calibri"/>
-                <a:ea typeface="Calibri"/>
-                <a:cs typeface="Calibri"/>
-              </a:rPr>
-              <a:t>Lab-Интеллект  ·  СМАРТА  ·  конфиденциально</a:t>
             </a:r>
           </a:p>
         </p:txBody>

</xml_diff>

<commit_message>
Add a slide 4 chart of incident drop vs engagement.
Visualizes Gallup Q12 −63% as an index chart (bottom quartile = 100, top = 37) in the empty third column.

Co-authored-by: lysakalenushka-hash <lysakalenushka-hash@users.noreply.github.com>
</commit_message>
<xml_diff>
--- a/issledovaniya/Lab-Intellekt_prodayushchaya-prezentaciya_v5.pptx
+++ b/issledovaniya/Lab-Intellekt_prodayushchaya-prezentaciya_v5.pptx
@@ -13316,6 +13316,76 @@
           </a:p>
         </p:txBody>
       </p:sp>
+      <p:sp>
+        <p:nvSpPr>
+          <p:cNvPr id="22" name="Rounded Rectangle 21"/>
+          <p:cNvSpPr/>
+          <p:nvPr/>
+        </p:nvSpPr>
+        <p:spPr>
+          <a:xfrm>
+            <a:off x="8092440" y="1874519"/>
+            <a:ext cx="3611880" cy="3246120"/>
+          </a:xfrm>
+          <a:prstGeom prst="roundRect">
+            <a:avLst>
+              <a:gd name="adj" fmla="val 16667"/>
+            </a:avLst>
+          </a:prstGeom>
+          <a:solidFill>
+            <a:srgbClr val="FFFFFF"/>
+          </a:solidFill>
+          <a:ln>
+            <a:noFill/>
+          </a:ln>
+          <a:effectLst/>
+        </p:spPr>
+        <p:style>
+          <a:lnRef idx="1">
+            <a:schemeClr val="accent1"/>
+          </a:lnRef>
+          <a:fillRef idx="3">
+            <a:schemeClr val="accent1"/>
+          </a:fillRef>
+          <a:effectRef idx="2">
+            <a:schemeClr val="accent1"/>
+          </a:effectRef>
+          <a:fontRef idx="minor">
+            <a:schemeClr val="lt1"/>
+          </a:fontRef>
+        </p:style>
+        <p:txBody>
+          <a:bodyPr rtlCol="0" anchor="ctr"/>
+          <a:lstStyle/>
+          <a:p>
+            <a:pPr algn="ctr"/>
+          </a:p>
+        </p:txBody>
+      </p:sp>
+      <p:pic>
+        <p:nvPicPr>
+          <p:cNvPr id="23" name="Picture 22" descr="slide4-incidents-vovlechennost.png"/>
+          <p:cNvPicPr>
+            <a:picLocks noChangeAspect="1"/>
+          </p:cNvPicPr>
+          <p:nvPr/>
+        </p:nvPicPr>
+        <p:blipFill>
+          <a:blip r:embed="rId3"/>
+          <a:stretch>
+            <a:fillRect/>
+          </a:stretch>
+        </p:blipFill>
+        <p:spPr>
+          <a:xfrm>
+            <a:off x="8162440" y="1924519"/>
+            <a:ext cx="3471880" cy="3146120"/>
+          </a:xfrm>
+          <a:prstGeom prst="rect">
+            <a:avLst/>
+          </a:prstGeom>
+        </p:spPr>
+      </p:pic>
     </p:spTree>
   </p:cSld>
   <p:clrMapOvr>

</xml_diff>

<commit_message>
Replace slide 5 cost cards with an illuminated loss scale.
Marks in order: 16 million lost work time, 3 million training administration, then 500 thousand lost shift / accident.

Co-authored-by: lysakalenushka-hash <lysakalenushka-hash@users.noreply.github.com>
</commit_message>
<xml_diff>
--- a/issledovaniya/Lab-Intellekt_prodayushchaya-prezentaciya_v5.pptx
+++ b/issledovaniya/Lab-Intellekt_prodayushchaya-prezentaciya_v5.pptx
@@ -13728,879 +13728,6 @@
       </p:sp>
       <p:sp>
         <p:nvSpPr>
-          <p:cNvPr id="7" name="Rounded Rectangle 6"/>
-          <p:cNvSpPr/>
-          <p:nvPr/>
-        </p:nvSpPr>
-        <p:spPr>
-          <a:xfrm>
-            <a:off x="502920" y="1874519"/>
-            <a:ext cx="3611880" cy="3977639"/>
-          </a:xfrm>
-          <a:prstGeom prst="roundRect">
-            <a:avLst/>
-          </a:prstGeom>
-          <a:solidFill>
-            <a:srgbClr val="FFFFFF"/>
-          </a:solidFill>
-          <a:ln w="12700">
-            <a:solidFill>
-              <a:srgbClr val="D8DEE6"/>
-            </a:solidFill>
-          </a:ln>
-          <a:effectLst/>
-        </p:spPr>
-        <p:style>
-          <a:lnRef idx="1">
-            <a:schemeClr val="accent1"/>
-          </a:lnRef>
-          <a:fillRef idx="3">
-            <a:schemeClr val="accent1"/>
-          </a:fillRef>
-          <a:effectRef idx="2">
-            <a:schemeClr val="accent1"/>
-          </a:effectRef>
-          <a:fontRef idx="minor">
-            <a:schemeClr val="lt1"/>
-          </a:fontRef>
-        </p:style>
-        <p:txBody>
-          <a:bodyPr rtlCol="0" anchor="ctr"/>
-          <a:lstStyle/>
-          <a:p>
-            <a:pPr algn="ctr"/>
-            <a:endParaRPr/>
-          </a:p>
-        </p:txBody>
-      </p:sp>
-      <p:sp>
-        <p:nvSpPr>
-          <p:cNvPr id="8" name="Rectangle 7"/>
-          <p:cNvSpPr/>
-          <p:nvPr/>
-        </p:nvSpPr>
-        <p:spPr>
-          <a:xfrm>
-            <a:off x="502920" y="1874519"/>
-            <a:ext cx="3611880" cy="91440"/>
-          </a:xfrm>
-          <a:prstGeom prst="rect">
-            <a:avLst/>
-          </a:prstGeom>
-          <a:solidFill>
-            <a:srgbClr val="C0453C"/>
-          </a:solidFill>
-          <a:ln>
-            <a:noFill/>
-          </a:ln>
-          <a:effectLst/>
-        </p:spPr>
-        <p:style>
-          <a:lnRef idx="1">
-            <a:schemeClr val="accent1"/>
-          </a:lnRef>
-          <a:fillRef idx="3">
-            <a:schemeClr val="accent1"/>
-          </a:fillRef>
-          <a:effectRef idx="2">
-            <a:schemeClr val="accent1"/>
-          </a:effectRef>
-          <a:fontRef idx="minor">
-            <a:schemeClr val="lt1"/>
-          </a:fontRef>
-        </p:style>
-        <p:txBody>
-          <a:bodyPr rtlCol="0" anchor="ctr"/>
-          <a:lstStyle/>
-          <a:p>
-            <a:pPr algn="ctr"/>
-            <a:endParaRPr/>
-          </a:p>
-        </p:txBody>
-      </p:sp>
-      <p:sp>
-        <p:nvSpPr>
-          <p:cNvPr id="9" name="TextBox 8"/>
-          <p:cNvSpPr txBox="1"/>
-          <p:nvPr/>
-        </p:nvSpPr>
-        <p:spPr>
-          <a:xfrm>
-            <a:off x="731520" y="2148840"/>
-            <a:ext cx="3154680" cy="914400"/>
-          </a:xfrm>
-          <a:prstGeom prst="rect">
-            <a:avLst/>
-          </a:prstGeom>
-          <a:noFill/>
-        </p:spPr>
-        <p:txBody>
-          <a:bodyPr wrap="square" anchor="t"/>
-          <a:lstStyle/>
-          <a:p>
-            <a:pPr algn="l"/>
-            <a:r>
-              <a:rPr lang="ru-RU" b="0" dirty="0" sz="1500" i="0">
-                <a:solidFill>
-                  <a:srgbClr val="5B6778"/>
-                </a:solidFill>
-                <a:latin typeface="Calibri"/>
-                <a:ea typeface="Calibri"/>
-                <a:cs typeface="Calibri"/>
-              </a:rPr>
-              <a:t>Потеря рабочего времени</a:t>
-            </a:r>
-            <a:endParaRPr sz="1800" b="1" i="0" dirty="0">
-              <a:solidFill>
-                <a:srgbClr val="0B1F3A"/>
-              </a:solidFill>
-              <a:latin typeface="Calibri"/>
-              <a:ea typeface="Calibri"/>
-              <a:cs typeface="Calibri"/>
-            </a:endParaRPr>
-          </a:p>
-        </p:txBody>
-      </p:sp>
-      <p:sp>
-        <p:nvSpPr>
-          <p:cNvPr id="10" name="TextBox 9"/>
-          <p:cNvSpPr txBox="1"/>
-          <p:nvPr/>
-        </p:nvSpPr>
-        <p:spPr>
-          <a:xfrm>
-            <a:off x="731520" y="3108960"/>
-            <a:ext cx="3154680" cy="1280160"/>
-          </a:xfrm>
-          <a:prstGeom prst="rect">
-            <a:avLst/>
-          </a:prstGeom>
-          <a:noFill/>
-        </p:spPr>
-        <p:txBody>
-          <a:bodyPr wrap="square" anchor="t"/>
-          <a:lstStyle/>
-          <a:p>
-            <a:pPr algn="l"/>
-            <a:r>
-              <a:rPr lang="ru-RU" sz="1500" dirty="0" b="0" i="0">
-                <a:solidFill>
-                  <a:srgbClr val="5B6778"/>
-                </a:solidFill>
-                <a:latin typeface="Calibri"/>
-                <a:ea typeface="Calibri"/>
-                <a:cs typeface="Calibri"/>
-              </a:rPr>
-              <a:t>Оплата времени, затраченного работниками на обучение</a:t>
-            </a:r>
-            <a:endParaRPr sz="1500" b="0" i="0" dirty="0">
-              <a:solidFill>
-                <a:srgbClr val="5B6778"/>
-              </a:solidFill>
-              <a:latin typeface="Calibri"/>
-              <a:ea typeface="Calibri"/>
-              <a:cs typeface="Calibri"/>
-            </a:endParaRPr>
-          </a:p>
-        </p:txBody>
-      </p:sp>
-      <p:sp>
-        <p:nvSpPr>
-          <p:cNvPr id="11" name="TextBox 10"/>
-          <p:cNvSpPr txBox="1"/>
-          <p:nvPr/>
-        </p:nvSpPr>
-        <p:spPr>
-          <a:xfrm>
-            <a:off x="731520" y="4754880"/>
-            <a:ext cx="3154680" cy="640080"/>
-          </a:xfrm>
-          <a:prstGeom prst="rect">
-            <a:avLst/>
-          </a:prstGeom>
-          <a:noFill/>
-        </p:spPr>
-        <p:txBody>
-          <a:bodyPr wrap="square" anchor="t"/>
-          <a:lstStyle/>
-          <a:p>
-            <a:pPr algn="l"/>
-            <a:r>
-              <a:rPr sz="1500" b="1" i="0" dirty="0" err="1">
-                <a:solidFill>
-                  <a:srgbClr val="C0453C"/>
-                </a:solidFill>
-                <a:latin typeface="Calibri"/>
-                <a:ea typeface="Calibri"/>
-                <a:cs typeface="Calibri"/>
-              </a:rPr>
-              <a:t>Ваша</a:t>
-            </a:r>
-            <a:r>
-              <a:rPr sz="1500" b="1" i="0" dirty="0">
-                <a:solidFill>
-                  <a:srgbClr val="C0453C"/>
-                </a:solidFill>
-                <a:latin typeface="Calibri"/>
-                <a:ea typeface="Calibri"/>
-                <a:cs typeface="Calibri"/>
-              </a:rPr>
-              <a:t> </a:t>
-            </a:r>
-            <a:r>
-              <a:rPr sz="1500" b="1" i="0" dirty="0" err="1">
-                <a:solidFill>
-                  <a:srgbClr val="C0453C"/>
-                </a:solidFill>
-                <a:latin typeface="Calibri"/>
-                <a:ea typeface="Calibri"/>
-                <a:cs typeface="Calibri"/>
-              </a:rPr>
-              <a:t>цифра</a:t>
-            </a:r>
-            <a:r>
-              <a:rPr sz="1500" b="1" i="0" dirty="0">
-                <a:solidFill>
-                  <a:srgbClr val="C0453C"/>
-                </a:solidFill>
-                <a:latin typeface="Calibri"/>
-                <a:ea typeface="Calibri"/>
-                <a:cs typeface="Calibri"/>
-              </a:rPr>
-              <a:t>: __</a:t>
-            </a:r>
-            <a:r>
-              <a:rPr lang="ru-RU" sz="1500" b="1" i="0" dirty="0">
-                <a:solidFill>
-                  <a:srgbClr val="C0453C"/>
-                </a:solidFill>
-                <a:latin typeface="Calibri"/>
-                <a:ea typeface="Calibri"/>
-                <a:cs typeface="Calibri"/>
-              </a:rPr>
-              <a:t>16 млн. </a:t>
-            </a:r>
-            <a:r>
-              <a:rPr sz="1500" b="1" i="0" dirty="0">
-                <a:solidFill>
-                  <a:srgbClr val="C0453C"/>
-                </a:solidFill>
-                <a:latin typeface="Calibri"/>
-                <a:ea typeface="Calibri"/>
-                <a:cs typeface="Calibri"/>
-              </a:rPr>
-              <a:t> ₽</a:t>
-            </a:r>
-          </a:p>
-        </p:txBody>
-      </p:sp>
-      <p:sp>
-        <p:nvSpPr>
-          <p:cNvPr id="12" name="Rounded Rectangle 11"/>
-          <p:cNvSpPr/>
-          <p:nvPr/>
-        </p:nvSpPr>
-        <p:spPr>
-          <a:xfrm>
-            <a:off x="4297680" y="1874519"/>
-            <a:ext cx="3611880" cy="3977639"/>
-          </a:xfrm>
-          <a:prstGeom prst="roundRect">
-            <a:avLst/>
-          </a:prstGeom>
-          <a:solidFill>
-            <a:srgbClr val="FFFFFF"/>
-          </a:solidFill>
-          <a:ln w="12700">
-            <a:solidFill>
-              <a:srgbClr val="D8DEE6"/>
-            </a:solidFill>
-          </a:ln>
-          <a:effectLst/>
-        </p:spPr>
-        <p:style>
-          <a:lnRef idx="1">
-            <a:schemeClr val="accent1"/>
-          </a:lnRef>
-          <a:fillRef idx="3">
-            <a:schemeClr val="accent1"/>
-          </a:fillRef>
-          <a:effectRef idx="2">
-            <a:schemeClr val="accent1"/>
-          </a:effectRef>
-          <a:fontRef idx="minor">
-            <a:schemeClr val="lt1"/>
-          </a:fontRef>
-        </p:style>
-        <p:txBody>
-          <a:bodyPr rtlCol="0" anchor="ctr"/>
-          <a:lstStyle/>
-          <a:p>
-            <a:pPr algn="ctr"/>
-            <a:endParaRPr/>
-          </a:p>
-        </p:txBody>
-      </p:sp>
-      <p:sp>
-        <p:nvSpPr>
-          <p:cNvPr id="13" name="Rectangle 12"/>
-          <p:cNvSpPr/>
-          <p:nvPr/>
-        </p:nvSpPr>
-        <p:spPr>
-          <a:xfrm>
-            <a:off x="4297680" y="1874519"/>
-            <a:ext cx="3611880" cy="91440"/>
-          </a:xfrm>
-          <a:prstGeom prst="rect">
-            <a:avLst/>
-          </a:prstGeom>
-          <a:solidFill>
-            <a:srgbClr val="C0453C"/>
-          </a:solidFill>
-          <a:ln>
-            <a:noFill/>
-          </a:ln>
-          <a:effectLst/>
-        </p:spPr>
-        <p:style>
-          <a:lnRef idx="1">
-            <a:schemeClr val="accent1"/>
-          </a:lnRef>
-          <a:fillRef idx="3">
-            <a:schemeClr val="accent1"/>
-          </a:fillRef>
-          <a:effectRef idx="2">
-            <a:schemeClr val="accent1"/>
-          </a:effectRef>
-          <a:fontRef idx="minor">
-            <a:schemeClr val="lt1"/>
-          </a:fontRef>
-        </p:style>
-        <p:txBody>
-          <a:bodyPr rtlCol="0" anchor="ctr"/>
-          <a:lstStyle/>
-          <a:p>
-            <a:pPr algn="ctr"/>
-            <a:endParaRPr/>
-          </a:p>
-        </p:txBody>
-      </p:sp>
-      <p:sp>
-        <p:nvSpPr>
-          <p:cNvPr id="14" name="TextBox 13"/>
-          <p:cNvSpPr txBox="1"/>
-          <p:nvPr/>
-        </p:nvSpPr>
-        <p:spPr>
-          <a:xfrm>
-            <a:off x="4526280" y="2148840"/>
-            <a:ext cx="3154680" cy="914400"/>
-          </a:xfrm>
-          <a:prstGeom prst="rect">
-            <a:avLst/>
-          </a:prstGeom>
-          <a:noFill/>
-        </p:spPr>
-        <p:txBody>
-          <a:bodyPr wrap="square" anchor="t"/>
-          <a:lstStyle/>
-          <a:p>
-            <a:pPr algn="l"/>
-            <a:r>
-              <a:rPr sz="1500" b="0" i="0">
-                <a:solidFill>
-                  <a:srgbClr val="5B6778"/>
-                </a:solidFill>
-                <a:latin typeface="Calibri"/>
-                <a:ea typeface="Calibri"/>
-                <a:cs typeface="Calibri"/>
-              </a:rPr>
-              <a:t>Потеря смены / НС</a:t>
-            </a:r>
-          </a:p>
-        </p:txBody>
-      </p:sp>
-      <p:sp>
-        <p:nvSpPr>
-          <p:cNvPr id="15" name="TextBox 14"/>
-          <p:cNvSpPr txBox="1"/>
-          <p:nvPr/>
-        </p:nvSpPr>
-        <p:spPr>
-          <a:xfrm>
-            <a:off x="4526280" y="3108960"/>
-            <a:ext cx="3154680" cy="1280160"/>
-          </a:xfrm>
-          <a:prstGeom prst="rect">
-            <a:avLst/>
-          </a:prstGeom>
-          <a:noFill/>
-        </p:spPr>
-        <p:txBody>
-          <a:bodyPr wrap="square" anchor="t"/>
-          <a:lstStyle/>
-          <a:p>
-            <a:pPr algn="l"/>
-            <a:r>
-              <a:rPr sz="1500" b="0" i="0" dirty="0" err="1">
-                <a:solidFill>
-                  <a:srgbClr val="5B6778"/>
-                </a:solidFill>
-                <a:latin typeface="Calibri"/>
-                <a:ea typeface="Calibri"/>
-                <a:cs typeface="Calibri"/>
-              </a:rPr>
-              <a:t>Больничный</a:t>
-            </a:r>
-            <a:r>
-              <a:rPr sz="1500" b="0" i="0" dirty="0">
-                <a:solidFill>
-                  <a:srgbClr val="5B6778"/>
-                </a:solidFill>
-                <a:latin typeface="Calibri"/>
-                <a:ea typeface="Calibri"/>
-                <a:cs typeface="Calibri"/>
-              </a:rPr>
-              <a:t>, </a:t>
-            </a:r>
-            <a:r>
-              <a:rPr sz="1500" b="0" i="0" dirty="0" err="1">
-                <a:solidFill>
-                  <a:srgbClr val="5B6778"/>
-                </a:solidFill>
-                <a:latin typeface="Calibri"/>
-                <a:ea typeface="Calibri"/>
-                <a:cs typeface="Calibri"/>
-              </a:rPr>
-              <a:t>простой</a:t>
-            </a:r>
-            <a:r>
-              <a:rPr sz="1500" b="0" i="0" dirty="0">
-                <a:solidFill>
-                  <a:srgbClr val="5B6778"/>
-                </a:solidFill>
-                <a:latin typeface="Calibri"/>
-                <a:ea typeface="Calibri"/>
-                <a:cs typeface="Calibri"/>
-              </a:rPr>
-              <a:t>, </a:t>
-            </a:r>
-            <a:r>
-              <a:rPr sz="1500" b="0" i="0" dirty="0" err="1">
-                <a:solidFill>
-                  <a:srgbClr val="5B6778"/>
-                </a:solidFill>
-                <a:latin typeface="Calibri"/>
-                <a:ea typeface="Calibri"/>
-                <a:cs typeface="Calibri"/>
-              </a:rPr>
-              <a:t>расследование</a:t>
-            </a:r>
-            <a:endParaRPr lang="ru-RU" sz="1500" b="0" i="0" dirty="0">
-              <a:solidFill>
-                <a:srgbClr val="5B6778"/>
-              </a:solidFill>
-              <a:latin typeface="Calibri"/>
-              <a:ea typeface="Calibri"/>
-              <a:cs typeface="Calibri"/>
-            </a:endParaRPr>
-          </a:p>
-          <a:p>
-            <a:pPr algn="l"/>
-            <a:r>
-              <a:rPr lang="ru-RU" sz="1500" dirty="0" b="0" i="0">
-                <a:solidFill>
-                  <a:srgbClr val="5B6778"/>
-                </a:solidFill>
-                <a:latin typeface="Calibri"/>
-                <a:ea typeface="Calibri"/>
-                <a:cs typeface="Calibri"/>
-              </a:rPr>
-              <a:t> </a:t>
-            </a:r>
-            <a:endParaRPr sz="1500" b="0" i="0" dirty="0">
-              <a:solidFill>
-                <a:srgbClr val="5B6778"/>
-              </a:solidFill>
-              <a:latin typeface="Calibri"/>
-              <a:ea typeface="Calibri"/>
-              <a:cs typeface="Calibri"/>
-            </a:endParaRPr>
-          </a:p>
-        </p:txBody>
-      </p:sp>
-      <p:sp>
-        <p:nvSpPr>
-          <p:cNvPr id="16" name="TextBox 15"/>
-          <p:cNvSpPr txBox="1"/>
-          <p:nvPr/>
-        </p:nvSpPr>
-        <p:spPr>
-          <a:xfrm>
-            <a:off x="4526280" y="4754880"/>
-            <a:ext cx="3154680" cy="640080"/>
-          </a:xfrm>
-          <a:prstGeom prst="rect">
-            <a:avLst/>
-          </a:prstGeom>
-          <a:noFill/>
-        </p:spPr>
-        <p:txBody>
-          <a:bodyPr wrap="square" anchor="t"/>
-          <a:lstStyle/>
-          <a:p>
-            <a:pPr algn="l"/>
-            <a:r>
-              <a:rPr sz="1500" b="1" i="0" dirty="0" err="1">
-                <a:solidFill>
-                  <a:srgbClr val="C0453C"/>
-                </a:solidFill>
-                <a:latin typeface="Calibri"/>
-                <a:ea typeface="Calibri"/>
-                <a:cs typeface="Calibri"/>
-              </a:rPr>
-              <a:t>Ваша</a:t>
-            </a:r>
-            <a:r>
-              <a:rPr sz="1500" b="1" i="0" dirty="0">
-                <a:solidFill>
-                  <a:srgbClr val="C0453C"/>
-                </a:solidFill>
-                <a:latin typeface="Calibri"/>
-                <a:ea typeface="Calibri"/>
-                <a:cs typeface="Calibri"/>
-              </a:rPr>
-              <a:t> </a:t>
-            </a:r>
-            <a:r>
-              <a:rPr sz="1500" b="1" i="0" dirty="0" err="1">
-                <a:solidFill>
-                  <a:srgbClr val="C0453C"/>
-                </a:solidFill>
-                <a:latin typeface="Calibri"/>
-                <a:ea typeface="Calibri"/>
-                <a:cs typeface="Calibri"/>
-              </a:rPr>
-              <a:t>цифра</a:t>
-            </a:r>
-            <a:r>
-              <a:rPr sz="1500" b="1" i="0" dirty="0">
-                <a:solidFill>
-                  <a:srgbClr val="C0453C"/>
-                </a:solidFill>
-                <a:latin typeface="Calibri"/>
-                <a:ea typeface="Calibri"/>
-                <a:cs typeface="Calibri"/>
-              </a:rPr>
-              <a:t>: </a:t>
-            </a:r>
-            <a:r>
-              <a:rPr lang="ru-RU" sz="1500" b="1" i="0" dirty="0">
-                <a:solidFill>
-                  <a:srgbClr val="C0453C"/>
-                </a:solidFill>
-                <a:latin typeface="Calibri"/>
-                <a:ea typeface="Calibri"/>
-                <a:cs typeface="Calibri"/>
-              </a:rPr>
-              <a:t>от 500 тыс.</a:t>
-            </a:r>
-            <a:r>
-              <a:rPr sz="1500" b="1" i="0" dirty="0">
-                <a:solidFill>
-                  <a:srgbClr val="C0453C"/>
-                </a:solidFill>
-                <a:latin typeface="Calibri"/>
-                <a:ea typeface="Calibri"/>
-                <a:cs typeface="Calibri"/>
-              </a:rPr>
-              <a:t> ₽</a:t>
-            </a:r>
-          </a:p>
-        </p:txBody>
-      </p:sp>
-      <p:sp>
-        <p:nvSpPr>
-          <p:cNvPr id="17" name="Rounded Rectangle 16"/>
-          <p:cNvSpPr/>
-          <p:nvPr/>
-        </p:nvSpPr>
-        <p:spPr>
-          <a:xfrm>
-            <a:off x="8092440" y="1874519"/>
-            <a:ext cx="3611880" cy="3977639"/>
-          </a:xfrm>
-          <a:prstGeom prst="roundRect">
-            <a:avLst/>
-          </a:prstGeom>
-          <a:solidFill>
-            <a:srgbClr val="FFFFFF"/>
-          </a:solidFill>
-          <a:ln w="12700">
-            <a:solidFill>
-              <a:srgbClr val="D8DEE6"/>
-            </a:solidFill>
-          </a:ln>
-          <a:effectLst/>
-        </p:spPr>
-        <p:style>
-          <a:lnRef idx="1">
-            <a:schemeClr val="accent1"/>
-          </a:lnRef>
-          <a:fillRef idx="3">
-            <a:schemeClr val="accent1"/>
-          </a:fillRef>
-          <a:effectRef idx="2">
-            <a:schemeClr val="accent1"/>
-          </a:effectRef>
-          <a:fontRef idx="minor">
-            <a:schemeClr val="lt1"/>
-          </a:fontRef>
-        </p:style>
-        <p:txBody>
-          <a:bodyPr rtlCol="0" anchor="ctr"/>
-          <a:lstStyle/>
-          <a:p>
-            <a:pPr algn="ctr"/>
-            <a:endParaRPr/>
-          </a:p>
-        </p:txBody>
-      </p:sp>
-      <p:sp>
-        <p:nvSpPr>
-          <p:cNvPr id="18" name="Rectangle 17"/>
-          <p:cNvSpPr/>
-          <p:nvPr/>
-        </p:nvSpPr>
-        <p:spPr>
-          <a:xfrm>
-            <a:off x="8092440" y="1874519"/>
-            <a:ext cx="3611880" cy="91440"/>
-          </a:xfrm>
-          <a:prstGeom prst="rect">
-            <a:avLst/>
-          </a:prstGeom>
-          <a:solidFill>
-            <a:srgbClr val="C0453C"/>
-          </a:solidFill>
-          <a:ln>
-            <a:noFill/>
-          </a:ln>
-          <a:effectLst/>
-        </p:spPr>
-        <p:style>
-          <a:lnRef idx="1">
-            <a:schemeClr val="accent1"/>
-          </a:lnRef>
-          <a:fillRef idx="3">
-            <a:schemeClr val="accent1"/>
-          </a:fillRef>
-          <a:effectRef idx="2">
-            <a:schemeClr val="accent1"/>
-          </a:effectRef>
-          <a:fontRef idx="minor">
-            <a:schemeClr val="lt1"/>
-          </a:fontRef>
-        </p:style>
-        <p:txBody>
-          <a:bodyPr rtlCol="0" anchor="ctr"/>
-          <a:lstStyle/>
-          <a:p>
-            <a:pPr algn="ctr"/>
-            <a:endParaRPr/>
-          </a:p>
-        </p:txBody>
-      </p:sp>
-      <p:sp>
-        <p:nvSpPr>
-          <p:cNvPr id="19" name="TextBox 18"/>
-          <p:cNvSpPr txBox="1"/>
-          <p:nvPr/>
-        </p:nvSpPr>
-        <p:spPr>
-          <a:xfrm>
-            <a:off x="8321040" y="2148840"/>
-            <a:ext cx="3154680" cy="914400"/>
-          </a:xfrm>
-          <a:prstGeom prst="rect">
-            <a:avLst/>
-          </a:prstGeom>
-          <a:noFill/>
-        </p:spPr>
-        <p:txBody>
-          <a:bodyPr wrap="square" anchor="t"/>
-          <a:lstStyle/>
-          <a:p>
-            <a:pPr algn="l"/>
-            <a:r>
-              <a:rPr lang="ru-RU" sz="1500" b="0" i="0" dirty="0">
-                <a:solidFill>
-                  <a:srgbClr val="5B6778"/>
-                </a:solidFill>
-                <a:latin typeface="Calibri"/>
-                <a:ea typeface="Calibri"/>
-                <a:cs typeface="Calibri"/>
-              </a:rPr>
-              <a:t>Стоимость организации </a:t>
-            </a:r>
-            <a:r>
-              <a:rPr lang="ru-RU" sz="1500" b="0" i="0" dirty="0" err="1">
-                <a:solidFill>
-                  <a:srgbClr val="5B6778"/>
-                </a:solidFill>
-                <a:latin typeface="Calibri"/>
-                <a:ea typeface="Calibri"/>
-                <a:cs typeface="Calibri"/>
-              </a:rPr>
-              <a:t>обучени</a:t>
-            </a:r>
-            <a:r>
-              <a:rPr sz="1500" b="0" i="0" dirty="0">
-                <a:solidFill>
-                  <a:srgbClr val="5B6778"/>
-                </a:solidFill>
-                <a:latin typeface="Calibri"/>
-                <a:ea typeface="Calibri"/>
-                <a:cs typeface="Calibri"/>
-              </a:rPr>
-              <a:t> «</a:t>
-            </a:r>
-            <a:r>
-              <a:rPr sz="1500" b="0" i="0" dirty="0" err="1">
-                <a:solidFill>
-                  <a:srgbClr val="5B6778"/>
-                </a:solidFill>
-                <a:latin typeface="Calibri"/>
-                <a:ea typeface="Calibri"/>
-                <a:cs typeface="Calibri"/>
-              </a:rPr>
-              <a:t>для</a:t>
-            </a:r>
-            <a:r>
-              <a:rPr sz="1500" b="0" i="0" dirty="0">
-                <a:solidFill>
-                  <a:srgbClr val="5B6778"/>
-                </a:solidFill>
-                <a:latin typeface="Calibri"/>
-                <a:ea typeface="Calibri"/>
-                <a:cs typeface="Calibri"/>
-              </a:rPr>
-              <a:t> </a:t>
-            </a:r>
-            <a:r>
-              <a:rPr sz="1500" b="0" i="0" dirty="0" err="1">
-                <a:solidFill>
-                  <a:srgbClr val="5B6778"/>
-                </a:solidFill>
-                <a:latin typeface="Calibri"/>
-                <a:ea typeface="Calibri"/>
-                <a:cs typeface="Calibri"/>
-              </a:rPr>
-              <a:t>галочки</a:t>
-            </a:r>
-            <a:r>
-              <a:rPr sz="1500" b="0" i="0" dirty="0">
-                <a:solidFill>
-                  <a:srgbClr val="5B6778"/>
-                </a:solidFill>
-                <a:latin typeface="Calibri"/>
-                <a:ea typeface="Calibri"/>
-                <a:cs typeface="Calibri"/>
-              </a:rPr>
-              <a:t>»</a:t>
-            </a:r>
-          </a:p>
-        </p:txBody>
-      </p:sp>
-      <p:sp>
-        <p:nvSpPr>
-          <p:cNvPr id="20" name="TextBox 19"/>
-          <p:cNvSpPr txBox="1"/>
-          <p:nvPr/>
-        </p:nvSpPr>
-        <p:spPr>
-          <a:xfrm>
-            <a:off x="8321040" y="3108960"/>
-            <a:ext cx="3154680" cy="1280160"/>
-          </a:xfrm>
-          <a:prstGeom prst="rect">
-            <a:avLst/>
-          </a:prstGeom>
-          <a:noFill/>
-        </p:spPr>
-        <p:txBody>
-          <a:bodyPr wrap="square" anchor="t"/>
-          <a:lstStyle/>
-          <a:p>
-            <a:pPr algn="l"/>
-            <a:r>
-              <a:rPr lang="ru-RU" sz="1500" b="0" i="0" dirty="0">
-                <a:solidFill>
-                  <a:srgbClr val="5B6778"/>
-                </a:solidFill>
-                <a:latin typeface="Calibri"/>
-                <a:ea typeface="Calibri"/>
-                <a:cs typeface="Calibri"/>
-              </a:rPr>
-              <a:t>Стоимость договорных отношений и администрирования процесса</a:t>
-            </a:r>
-            <a:endParaRPr sz="1500" b="0" i="0" dirty="0">
-              <a:solidFill>
-                <a:srgbClr val="5B6778"/>
-              </a:solidFill>
-              <a:latin typeface="Calibri"/>
-              <a:ea typeface="Calibri"/>
-              <a:cs typeface="Calibri"/>
-            </a:endParaRPr>
-          </a:p>
-        </p:txBody>
-      </p:sp>
-      <p:sp>
-        <p:nvSpPr>
-          <p:cNvPr id="21" name="TextBox 20"/>
-          <p:cNvSpPr txBox="1"/>
-          <p:nvPr/>
-        </p:nvSpPr>
-        <p:spPr>
-          <a:xfrm>
-            <a:off x="8321040" y="4754880"/>
-            <a:ext cx="3154680" cy="640080"/>
-          </a:xfrm>
-          <a:prstGeom prst="rect">
-            <a:avLst/>
-          </a:prstGeom>
-          <a:noFill/>
-        </p:spPr>
-        <p:txBody>
-          <a:bodyPr wrap="square" anchor="t"/>
-          <a:lstStyle/>
-          <a:p>
-            <a:pPr algn="l"/>
-            <a:r>
-              <a:rPr lang="ru-RU" sz="1500" b="1" i="0" dirty="0">
-                <a:solidFill>
-                  <a:srgbClr val="C0453C"/>
-                </a:solidFill>
-                <a:latin typeface="Calibri"/>
-                <a:ea typeface="Calibri"/>
-                <a:cs typeface="Calibri"/>
-              </a:rPr>
-              <a:t>3 млн ₽</a:t>
-            </a:r>
-            <a:endParaRPr sz="1500" b="1" i="0" dirty="0">
-              <a:solidFill>
-                <a:srgbClr val="C0453C"/>
-              </a:solidFill>
-              <a:latin typeface="Calibri"/>
-              <a:ea typeface="Calibri"/>
-              <a:cs typeface="Calibri"/>
-            </a:endParaRPr>
-          </a:p>
-        </p:txBody>
-      </p:sp>
-      <p:sp>
-        <p:nvSpPr>
           <p:cNvPr id="23" name="TextBox 22"/>
           <p:cNvSpPr txBox="1"/>
           <p:nvPr/>
@@ -14634,6 +13761,30 @@
           </a:p>
         </p:txBody>
       </p:sp>
+      <p:pic>
+        <p:nvPicPr>
+          <p:cNvPr id="24" name="Picture 23" descr="slide5-shkala-poter.png"/>
+          <p:cNvPicPr>
+            <a:picLocks noChangeAspect="1"/>
+          </p:cNvPicPr>
+          <p:nvPr/>
+        </p:nvPicPr>
+        <p:blipFill>
+          <a:blip r:embed="rId3"/>
+          <a:stretch>
+            <a:fillRect/>
+          </a:stretch>
+        </p:blipFill>
+        <p:spPr>
+          <a:xfrm>
+            <a:off x="502920" y="1750000"/>
+            <a:ext cx="11155680" cy="4600000"/>
+          </a:xfrm>
+          <a:prstGeom prst="rect">
+            <a:avLst/>
+          </a:prstGeom>
+        </p:spPr>
+      </p:pic>
     </p:spTree>
   </p:cSld>
   <p:clrMapOvr>

</xml_diff>

<commit_message>
Add a closing commerce slide with web prices and an unpriced server option.
Web per-user rates come from the SMARTA microlearning proposal table. Server cost is left unspecified. Content development or adaptation is listed as an extra, priced from a statement of work.

Co-authored-by: lysakalenushka-hash <lysakalenushka-hash@users.noreply.github.com>
</commit_message>
<xml_diff>
--- a/issledovaniya/Lab-Intellekt_prodayushchaya-prezentaciya_v5.pptx
+++ b/issledovaniya/Lab-Intellekt_prodayushchaya-prezentaciya_v5.pptx
@@ -24,6 +24,7 @@
     <p:sldId id="269" r:id="rId15"/>
     <p:sldId id="272" r:id="rId16"/>
     <p:sldId id="273" r:id="rId17"/>
+    <p:sldId id="275" r:id="rId23"/>
   </p:sldIdLst>
   <p:sldSz cx="12192000" cy="6858000"/>
   <p:notesSz cx="6858000" cy="9144000"/>
@@ -491,6 +492,31 @@
         </p:nvSpPr>
         <p:spPr/>
       </p:sp>
+    </p:spTree>
+  </p:cSld>
+  <p:clrMapOvr>
+    <a:masterClrMapping/>
+  </p:clrMapOvr>
+</p:notes>
+</file>
+
+<file path=ppt/notesSlides/notesSlide11.xml><?xml version="1.0" encoding="utf-8"?>
+<p:notes xmlns:a="http://schemas.openxmlformats.org/drawingml/2006/main" xmlns:p="http://schemas.openxmlformats.org/presentationml/2006/main" xmlns:r="http://schemas.openxmlformats.org/officeDocument/2006/relationships">
+  <p:cSld>
+    <p:spTree>
+      <p:nvGrpSpPr>
+        <p:cNvPr id="1" name=""/>
+        <p:cNvGrpSpPr/>
+        <p:nvPr/>
+      </p:nvGrpSpPr>
+      <p:grpSpPr>
+        <a:xfrm>
+          <a:off x="0" y="0"/>
+          <a:ext cx="0" cy="0"/>
+          <a:chOff x="0" y="0"/>
+          <a:chExt cx="0" cy="0"/>
+        </a:xfrm>
+      </p:grpSpPr>
     </p:spTree>
   </p:cSld>
   <p:clrMapOvr>
@@ -4223,13 +4249,13 @@
             <a:r>
               <a:rPr sz="1100" b="0" i="0">
                 <a:solidFill>
-                  <a:srgbClr val="8AA0B8"/>
-                </a:solidFill>
-                <a:latin typeface="Calibri"/>
-                <a:ea typeface="Calibri"/>
-                <a:cs typeface="Calibri"/>
-              </a:rPr>
-              <a:t>1  /  16</a:t>
+                  <a:srgbClr val="9AA3B0"/>
+                </a:solidFill>
+                <a:latin typeface="Calibri"/>
+                <a:ea typeface="Calibri"/>
+                <a:cs typeface="Calibri"/>
+              </a:rPr>
+              <a:t>1  /  17</a:t>
             </a:r>
           </a:p>
         </p:txBody>
@@ -5064,7 +5090,7 @@
                 <a:ea typeface="Calibri"/>
                 <a:cs typeface="Calibri"/>
               </a:rPr>
-              <a:t>10  /  16</a:t>
+              <a:t>10  /  17</a:t>
             </a:r>
           </a:p>
         </p:txBody>
@@ -6356,7 +6382,7 @@
                 <a:ea typeface="Calibri"/>
                 <a:cs typeface="Calibri"/>
               </a:rPr>
-              <a:t>11  /  16</a:t>
+              <a:t>11  /  17</a:t>
             </a:r>
           </a:p>
         </p:txBody>
@@ -6807,13 +6833,13 @@
             <a:r>
               <a:rPr sz="1100" b="0" i="0">
                 <a:solidFill>
-                  <a:srgbClr val="8AA0B8"/>
-                </a:solidFill>
-                <a:latin typeface="Calibri"/>
-                <a:ea typeface="Calibri"/>
-                <a:cs typeface="Calibri"/>
-              </a:rPr>
-              <a:t>12  /  16</a:t>
+                  <a:srgbClr val="9AA3B0"/>
+                </a:solidFill>
+                <a:latin typeface="Calibri"/>
+                <a:ea typeface="Calibri"/>
+                <a:cs typeface="Calibri"/>
+              </a:rPr>
+              <a:t>12  /  17</a:t>
             </a:r>
           </a:p>
         </p:txBody>
@@ -7534,7 +7560,7 @@
                 <a:ea typeface="Calibri"/>
                 <a:cs typeface="Calibri"/>
               </a:rPr>
-              <a:t>13  /  16</a:t>
+              <a:t>13  /  17</a:t>
             </a:r>
           </a:p>
         </p:txBody>
@@ -8404,7 +8430,7 @@
                 <a:ea typeface="Calibri"/>
                 <a:cs typeface="Calibri"/>
               </a:rPr>
-              <a:t>14  /  16</a:t>
+              <a:t>14  /  17</a:t>
             </a:r>
           </a:p>
         </p:txBody>
@@ -9248,7 +9274,7 @@
                 <a:ea typeface="Calibri"/>
                 <a:cs typeface="Calibri"/>
               </a:rPr>
-              <a:t>15  /  16</a:t>
+              <a:t>15  /  17</a:t>
             </a:r>
           </a:p>
         </p:txBody>
@@ -9513,7 +9539,7 @@
                 <a:ea typeface="Calibri"/>
                 <a:cs typeface="Calibri"/>
               </a:rPr>
-              <a:t>16  /  16</a:t>
+              <a:t>16  /  17</a:t>
             </a:r>
           </a:p>
         </p:txBody>
@@ -10004,6 +10030,999 @@
 </p:sld>
 </file>
 
+<file path=ppt/slides/slide17.xml><?xml version="1.0" encoding="utf-8"?>
+<p:sld xmlns:a="http://schemas.openxmlformats.org/drawingml/2006/main" xmlns:p="http://schemas.openxmlformats.org/presentationml/2006/main" xmlns:r="http://schemas.openxmlformats.org/officeDocument/2006/relationships">
+  <p:cSld>
+    <p:spTree>
+      <p:nvGrpSpPr>
+        <p:cNvPr id="1" name=""/>
+        <p:cNvGrpSpPr/>
+        <p:nvPr/>
+      </p:nvGrpSpPr>
+      <p:grpSpPr/>
+      <p:sp>
+        <p:nvSpPr>
+          <p:cNvPr id="2" name="Rectangle 1"/>
+          <p:cNvSpPr/>
+          <p:nvPr/>
+        </p:nvSpPr>
+        <p:spPr>
+          <a:xfrm>
+            <a:off x="0" y="0"/>
+            <a:ext cx="12192000" cy="6858000"/>
+          </a:xfrm>
+          <a:prstGeom prst="rect">
+            <a:avLst/>
+          </a:prstGeom>
+          <a:solidFill>
+            <a:srgbClr val="F5F7FA"/>
+          </a:solidFill>
+          <a:ln>
+            <a:noFill/>
+          </a:ln>
+          <a:effectLst/>
+        </p:spPr>
+        <p:style>
+          <a:lnRef idx="1">
+            <a:schemeClr val="accent1"/>
+          </a:lnRef>
+          <a:fillRef idx="3">
+            <a:schemeClr val="accent1"/>
+          </a:fillRef>
+          <a:effectRef idx="2">
+            <a:schemeClr val="accent1"/>
+          </a:effectRef>
+          <a:fontRef idx="minor">
+            <a:schemeClr val="lt1"/>
+          </a:fontRef>
+        </p:style>
+        <p:txBody>
+          <a:bodyPr rtlCol="0" anchor="ctr"/>
+          <a:lstStyle/>
+          <a:p>
+            <a:pPr algn="ctr"/>
+          </a:p>
+        </p:txBody>
+      </p:sp>
+      <p:sp>
+        <p:nvSpPr>
+          <p:cNvPr id="3" name="Rectangle 2"/>
+          <p:cNvSpPr/>
+          <p:nvPr/>
+        </p:nvSpPr>
+        <p:spPr>
+          <a:xfrm>
+            <a:off x="0" y="0"/>
+            <a:ext cx="109728" cy="6858000"/>
+          </a:xfrm>
+          <a:prstGeom prst="rect">
+            <a:avLst/>
+          </a:prstGeom>
+          <a:solidFill>
+            <a:srgbClr val="1A9B8A"/>
+          </a:solidFill>
+          <a:ln>
+            <a:noFill/>
+          </a:ln>
+          <a:effectLst/>
+        </p:spPr>
+        <p:style>
+          <a:lnRef idx="1">
+            <a:schemeClr val="accent1"/>
+          </a:lnRef>
+          <a:fillRef idx="3">
+            <a:schemeClr val="accent1"/>
+          </a:fillRef>
+          <a:effectRef idx="2">
+            <a:schemeClr val="accent1"/>
+          </a:effectRef>
+          <a:fontRef idx="minor">
+            <a:schemeClr val="lt1"/>
+          </a:fontRef>
+        </p:style>
+        <p:txBody>
+          <a:bodyPr rtlCol="0" anchor="ctr"/>
+          <a:lstStyle/>
+          <a:p>
+            <a:pPr algn="ctr"/>
+          </a:p>
+        </p:txBody>
+      </p:sp>
+      <p:sp>
+        <p:nvSpPr>
+          <p:cNvPr id="4" name="Rectangle 3"/>
+          <p:cNvSpPr/>
+          <p:nvPr/>
+        </p:nvSpPr>
+        <p:spPr>
+          <a:xfrm>
+            <a:off x="0" y="0"/>
+            <a:ext cx="12192000" cy="73152"/>
+          </a:xfrm>
+          <a:prstGeom prst="rect">
+            <a:avLst/>
+          </a:prstGeom>
+          <a:solidFill>
+            <a:srgbClr val="1A9B8A"/>
+          </a:solidFill>
+          <a:ln>
+            <a:noFill/>
+          </a:ln>
+          <a:effectLst/>
+        </p:spPr>
+        <p:style>
+          <a:lnRef idx="1">
+            <a:schemeClr val="accent1"/>
+          </a:lnRef>
+          <a:fillRef idx="3">
+            <a:schemeClr val="accent1"/>
+          </a:fillRef>
+          <a:effectRef idx="2">
+            <a:schemeClr val="accent1"/>
+          </a:effectRef>
+          <a:fontRef idx="minor">
+            <a:schemeClr val="lt1"/>
+          </a:fontRef>
+        </p:style>
+        <p:txBody>
+          <a:bodyPr rtlCol="0" anchor="ctr"/>
+          <a:lstStyle/>
+          <a:p>
+            <a:pPr algn="ctr"/>
+          </a:p>
+        </p:txBody>
+      </p:sp>
+      <p:sp>
+        <p:nvSpPr>
+          <p:cNvPr id="5" name="TextBox 4"/>
+          <p:cNvSpPr txBox="1"/>
+          <p:nvPr/>
+        </p:nvSpPr>
+        <p:spPr>
+          <a:xfrm>
+            <a:off x="502920" y="201168"/>
+            <a:ext cx="10972800" cy="292608"/>
+          </a:xfrm>
+          <a:prstGeom prst="rect">
+            <a:avLst/>
+          </a:prstGeom>
+          <a:noFill/>
+        </p:spPr>
+        <p:txBody>
+          <a:bodyPr wrap="square" anchor="t">
+            <a:spAutoFit/>
+          </a:bodyPr>
+          <a:lstStyle/>
+          <a:p>
+            <a:pPr algn="l"/>
+            <a:r>
+              <a:rPr sz="1200" b="1" i="0">
+                <a:solidFill>
+                  <a:srgbClr val="1A9B8A"/>
+                </a:solidFill>
+                <a:latin typeface="Calibri"/>
+                <a:ea typeface="Calibri"/>
+                <a:cs typeface="Calibri"/>
+              </a:rPr>
+              <a:t>КОММЕРЦИЯ</a:t>
+            </a:r>
+          </a:p>
+        </p:txBody>
+      </p:sp>
+      <p:sp>
+        <p:nvSpPr>
+          <p:cNvPr id="6" name="TextBox 5"/>
+          <p:cNvSpPr txBox="1"/>
+          <p:nvPr/>
+        </p:nvSpPr>
+        <p:spPr>
+          <a:xfrm>
+            <a:off x="502920" y="457200"/>
+            <a:ext cx="11155680" cy="720000"/>
+          </a:xfrm>
+          <a:prstGeom prst="rect">
+            <a:avLst/>
+          </a:prstGeom>
+          <a:noFill/>
+        </p:spPr>
+        <p:txBody>
+          <a:bodyPr wrap="square" anchor="t">
+            <a:spAutoFit/>
+          </a:bodyPr>
+          <a:lstStyle/>
+          <a:p>
+            <a:pPr algn="l"/>
+            <a:r>
+              <a:rPr sz="2800" b="1" i="0">
+                <a:solidFill>
+                  <a:srgbClr val="1A2332"/>
+                </a:solidFill>
+                <a:latin typeface="Calibri"/>
+                <a:ea typeface="Calibri"/>
+                <a:cs typeface="Calibri"/>
+              </a:rPr>
+              <a:t>Веб-версия и серверная версия</a:t>
+            </a:r>
+          </a:p>
+        </p:txBody>
+      </p:sp>
+      <p:sp>
+        <p:nvSpPr>
+          <p:cNvPr id="7" name="Rounded Rectangle 6"/>
+          <p:cNvSpPr/>
+          <p:nvPr/>
+        </p:nvSpPr>
+        <p:spPr>
+          <a:xfrm>
+            <a:off x="502920" y="1680000"/>
+            <a:ext cx="6400800" cy="3650000"/>
+          </a:xfrm>
+          <a:prstGeom prst="roundRect">
+            <a:avLst/>
+          </a:prstGeom>
+          <a:solidFill>
+            <a:srgbClr val="FFFFFF"/>
+          </a:solidFill>
+          <a:ln>
+            <a:noFill/>
+          </a:ln>
+          <a:effectLst/>
+        </p:spPr>
+        <p:style>
+          <a:lnRef idx="1">
+            <a:schemeClr val="accent1"/>
+          </a:lnRef>
+          <a:fillRef idx="3">
+            <a:schemeClr val="accent1"/>
+          </a:fillRef>
+          <a:effectRef idx="2">
+            <a:schemeClr val="accent1"/>
+          </a:effectRef>
+          <a:fontRef idx="minor">
+            <a:schemeClr val="lt1"/>
+          </a:fontRef>
+        </p:style>
+        <p:txBody>
+          <a:bodyPr rtlCol="0" anchor="ctr"/>
+          <a:lstStyle/>
+          <a:p>
+            <a:pPr algn="ctr"/>
+          </a:p>
+        </p:txBody>
+      </p:sp>
+      <p:sp>
+        <p:nvSpPr>
+          <p:cNvPr id="8" name="TextBox 7"/>
+          <p:cNvSpPr txBox="1"/>
+          <p:nvPr/>
+        </p:nvSpPr>
+        <p:spPr>
+          <a:xfrm>
+            <a:off x="731520" y="1780000"/>
+            <a:ext cx="5943600" cy="380000"/>
+          </a:xfrm>
+          <a:prstGeom prst="rect">
+            <a:avLst/>
+          </a:prstGeom>
+          <a:noFill/>
+        </p:spPr>
+        <p:txBody>
+          <a:bodyPr wrap="square" anchor="t">
+            <a:spAutoFit/>
+          </a:bodyPr>
+          <a:lstStyle/>
+          <a:p>
+            <a:pPr algn="l"/>
+            <a:r>
+              <a:rPr sz="2000" b="1" i="0">
+                <a:solidFill>
+                  <a:srgbClr val="1A9B8A"/>
+                </a:solidFill>
+                <a:latin typeface="Calibri"/>
+                <a:ea typeface="Calibri"/>
+                <a:cs typeface="Calibri"/>
+              </a:rPr>
+              <a:t>Веб-версия</a:t>
+            </a:r>
+          </a:p>
+        </p:txBody>
+      </p:sp>
+      <p:sp>
+        <p:nvSpPr>
+          <p:cNvPr id="9" name="TextBox 8"/>
+          <p:cNvSpPr txBox="1"/>
+          <p:nvPr/>
+        </p:nvSpPr>
+        <p:spPr>
+          <a:xfrm>
+            <a:off x="731520" y="2140000"/>
+            <a:ext cx="5943600" cy="420000"/>
+          </a:xfrm>
+          <a:prstGeom prst="rect">
+            <a:avLst/>
+          </a:prstGeom>
+          <a:noFill/>
+        </p:spPr>
+        <p:txBody>
+          <a:bodyPr wrap="square" anchor="t">
+            <a:spAutoFit/>
+          </a:bodyPr>
+          <a:lstStyle/>
+          <a:p>
+            <a:pPr algn="l"/>
+            <a:r>
+              <a:rPr sz="1400" b="0" i="0">
+                <a:solidFill>
+                  <a:srgbClr val="5B6778"/>
+                </a:solidFill>
+                <a:latin typeface="Calibri"/>
+                <a:ea typeface="Calibri"/>
+                <a:cs typeface="Calibri"/>
+              </a:rPr>
+              <a:t>С готовым контентом. Цена за 1 работника.</a:t>
+            </a:r>
+          </a:p>
+        </p:txBody>
+      </p:sp>
+      <p:graphicFrame>
+        <p:nvGraphicFramePr>
+          <p:cNvPr id="10" name="Table 9"/>
+          <p:cNvGraphicFramePr>
+            <a:graphicFrameLocks noGrp="1"/>
+          </p:cNvGraphicFramePr>
+          <p:nvPr/>
+        </p:nvGraphicFramePr>
+        <p:xfrm>
+          <a:off x="731520" y="2580000"/>
+          <a:ext cx="5943600" cy="2520000"/>
+        </p:xfrm>
+        <a:graphic>
+          <a:graphicData uri="http://schemas.openxmlformats.org/drawingml/2006/table">
+            <a:tbl>
+              <a:tblPr firstRow="1" bandRow="1">
+                <a:tableStyleId>{5C22544A-7EE6-4342-B048-85BDC9FD1C3A}</a:tableStyleId>
+              </a:tblPr>
+              <a:tblGrid>
+                <a:gridCol w="3328416"/>
+                <a:gridCol w="2615184"/>
+              </a:tblGrid>
+              <a:tr h="420000">
+                <a:tc>
+                  <a:txBody>
+                    <a:bodyPr/>
+                    <a:lstStyle/>
+                    <a:p>
+                      <a:pPr algn="l"/>
+                      <a:r>
+                        <a:rPr sz="1300" b="1" i="0">
+                          <a:solidFill>
+                            <a:srgbClr val="FFFFFF"/>
+                          </a:solidFill>
+                          <a:latin typeface="Calibri"/>
+                          <a:ea typeface="Calibri"/>
+                          <a:cs typeface="Calibri"/>
+                        </a:rPr>
+                        <a:t>Количество пользователей</a:t>
+                      </a:r>
+                    </a:p>
+                  </a:txBody>
+                  <a:tcPr anchor="ctr">
+                    <a:solidFill>
+                      <a:srgbClr val="1A9B8A"/>
+                    </a:solidFill>
+                  </a:tcPr>
+                </a:tc>
+                <a:tc>
+                  <a:txBody>
+                    <a:bodyPr/>
+                    <a:lstStyle/>
+                    <a:p>
+                      <a:pPr algn="r"/>
+                      <a:r>
+                        <a:rPr sz="1300" b="1" i="0">
+                          <a:solidFill>
+                            <a:srgbClr val="FFFFFF"/>
+                          </a:solidFill>
+                          <a:latin typeface="Calibri"/>
+                          <a:ea typeface="Calibri"/>
+                          <a:cs typeface="Calibri"/>
+                        </a:rPr>
+                        <a:t>Цена за 1 работника</a:t>
+                      </a:r>
+                    </a:p>
+                  </a:txBody>
+                  <a:tcPr anchor="ctr">
+                    <a:solidFill>
+                      <a:srgbClr val="1A9B8A"/>
+                    </a:solidFill>
+                  </a:tcPr>
+                </a:tc>
+              </a:tr>
+              <a:tr h="420000">
+                <a:tc>
+                  <a:txBody>
+                    <a:bodyPr/>
+                    <a:lstStyle/>
+                    <a:p>
+                      <a:pPr algn="l"/>
+                      <a:r>
+                        <a:rPr sz="1300" b="0" i="0">
+                          <a:solidFill>
+                            <a:srgbClr val="1A2332"/>
+                          </a:solidFill>
+                          <a:latin typeface="Calibri"/>
+                          <a:ea typeface="Calibri"/>
+                          <a:cs typeface="Calibri"/>
+                        </a:rPr>
+                        <a:t>0–50</a:t>
+                      </a:r>
+                    </a:p>
+                  </a:txBody>
+                  <a:tcPr anchor="ctr">
+                    <a:solidFill>
+                      <a:srgbClr val="FFFFFF"/>
+                    </a:solidFill>
+                  </a:tcPr>
+                </a:tc>
+                <a:tc>
+                  <a:txBody>
+                    <a:bodyPr/>
+                    <a:lstStyle/>
+                    <a:p>
+                      <a:pPr algn="r"/>
+                      <a:r>
+                        <a:rPr sz="1300" b="1" i="0">
+                          <a:solidFill>
+                            <a:srgbClr val="1A2332"/>
+                          </a:solidFill>
+                          <a:latin typeface="Calibri"/>
+                          <a:ea typeface="Calibri"/>
+                          <a:cs typeface="Calibri"/>
+                        </a:rPr>
+                        <a:t>490 ₽</a:t>
+                      </a:r>
+                    </a:p>
+                  </a:txBody>
+                  <a:tcPr anchor="ctr">
+                    <a:solidFill>
+                      <a:srgbClr val="FFFFFF"/>
+                    </a:solidFill>
+                  </a:tcPr>
+                </a:tc>
+              </a:tr>
+              <a:tr h="420000">
+                <a:tc>
+                  <a:txBody>
+                    <a:bodyPr/>
+                    <a:lstStyle/>
+                    <a:p>
+                      <a:pPr algn="l"/>
+                      <a:r>
+                        <a:rPr sz="1300" b="0" i="0">
+                          <a:solidFill>
+                            <a:srgbClr val="1A2332"/>
+                          </a:solidFill>
+                          <a:latin typeface="Calibri"/>
+                          <a:ea typeface="Calibri"/>
+                          <a:cs typeface="Calibri"/>
+                        </a:rPr>
+                        <a:t>50–300</a:t>
+                      </a:r>
+                    </a:p>
+                  </a:txBody>
+                  <a:tcPr anchor="ctr">
+                    <a:solidFill>
+                      <a:srgbClr val="F5F7FA"/>
+                    </a:solidFill>
+                  </a:tcPr>
+                </a:tc>
+                <a:tc>
+                  <a:txBody>
+                    <a:bodyPr/>
+                    <a:lstStyle/>
+                    <a:p>
+                      <a:pPr algn="r"/>
+                      <a:r>
+                        <a:rPr sz="1300" b="1" i="0">
+                          <a:solidFill>
+                            <a:srgbClr val="1A2332"/>
+                          </a:solidFill>
+                          <a:latin typeface="Calibri"/>
+                          <a:ea typeface="Calibri"/>
+                          <a:cs typeface="Calibri"/>
+                        </a:rPr>
+                        <a:t>460 ₽</a:t>
+                      </a:r>
+                    </a:p>
+                  </a:txBody>
+                  <a:tcPr anchor="ctr">
+                    <a:solidFill>
+                      <a:srgbClr val="F5F7FA"/>
+                    </a:solidFill>
+                  </a:tcPr>
+                </a:tc>
+              </a:tr>
+              <a:tr h="420000">
+                <a:tc>
+                  <a:txBody>
+                    <a:bodyPr/>
+                    <a:lstStyle/>
+                    <a:p>
+                      <a:pPr algn="l"/>
+                      <a:r>
+                        <a:rPr sz="1300" b="0" i="0">
+                          <a:solidFill>
+                            <a:srgbClr val="1A2332"/>
+                          </a:solidFill>
+                          <a:latin typeface="Calibri"/>
+                          <a:ea typeface="Calibri"/>
+                          <a:cs typeface="Calibri"/>
+                        </a:rPr>
+                        <a:t>300–1000</a:t>
+                      </a:r>
+                    </a:p>
+                  </a:txBody>
+                  <a:tcPr anchor="ctr">
+                    <a:solidFill>
+                      <a:srgbClr val="FFFFFF"/>
+                    </a:solidFill>
+                  </a:tcPr>
+                </a:tc>
+                <a:tc>
+                  <a:txBody>
+                    <a:bodyPr/>
+                    <a:lstStyle/>
+                    <a:p>
+                      <a:pPr algn="r"/>
+                      <a:r>
+                        <a:rPr sz="1300" b="1" i="0">
+                          <a:solidFill>
+                            <a:srgbClr val="1A2332"/>
+                          </a:solidFill>
+                          <a:latin typeface="Calibri"/>
+                          <a:ea typeface="Calibri"/>
+                          <a:cs typeface="Calibri"/>
+                        </a:rPr>
+                        <a:t>420 ₽</a:t>
+                      </a:r>
+                    </a:p>
+                  </a:txBody>
+                  <a:tcPr anchor="ctr">
+                    <a:solidFill>
+                      <a:srgbClr val="FFFFFF"/>
+                    </a:solidFill>
+                  </a:tcPr>
+                </a:tc>
+              </a:tr>
+              <a:tr h="420000">
+                <a:tc>
+                  <a:txBody>
+                    <a:bodyPr/>
+                    <a:lstStyle/>
+                    <a:p>
+                      <a:pPr algn="l"/>
+                      <a:r>
+                        <a:rPr sz="1300" b="0" i="0">
+                          <a:solidFill>
+                            <a:srgbClr val="1A2332"/>
+                          </a:solidFill>
+                          <a:latin typeface="Calibri"/>
+                          <a:ea typeface="Calibri"/>
+                          <a:cs typeface="Calibri"/>
+                        </a:rPr>
+                        <a:t>1000–5000</a:t>
+                      </a:r>
+                    </a:p>
+                  </a:txBody>
+                  <a:tcPr anchor="ctr">
+                    <a:solidFill>
+                      <a:srgbClr val="F5F7FA"/>
+                    </a:solidFill>
+                  </a:tcPr>
+                </a:tc>
+                <a:tc>
+                  <a:txBody>
+                    <a:bodyPr/>
+                    <a:lstStyle/>
+                    <a:p>
+                      <a:pPr algn="r"/>
+                      <a:r>
+                        <a:rPr sz="1300" b="1" i="0">
+                          <a:solidFill>
+                            <a:srgbClr val="1A2332"/>
+                          </a:solidFill>
+                          <a:latin typeface="Calibri"/>
+                          <a:ea typeface="Calibri"/>
+                          <a:cs typeface="Calibri"/>
+                        </a:rPr>
+                        <a:t>390 ₽</a:t>
+                      </a:r>
+                    </a:p>
+                  </a:txBody>
+                  <a:tcPr anchor="ctr">
+                    <a:solidFill>
+                      <a:srgbClr val="F5F7FA"/>
+                    </a:solidFill>
+                  </a:tcPr>
+                </a:tc>
+              </a:tr>
+              <a:tr h="420000">
+                <a:tc>
+                  <a:txBody>
+                    <a:bodyPr/>
+                    <a:lstStyle/>
+                    <a:p>
+                      <a:pPr algn="l"/>
+                      <a:r>
+                        <a:rPr sz="1300" b="0" i="0">
+                          <a:solidFill>
+                            <a:srgbClr val="1A2332"/>
+                          </a:solidFill>
+                          <a:latin typeface="Calibri"/>
+                          <a:ea typeface="Calibri"/>
+                          <a:cs typeface="Calibri"/>
+                        </a:rPr>
+                        <a:t>5000 и выше</a:t>
+                      </a:r>
+                    </a:p>
+                  </a:txBody>
+                  <a:tcPr anchor="ctr">
+                    <a:solidFill>
+                      <a:srgbClr val="FFFFFF"/>
+                    </a:solidFill>
+                  </a:tcPr>
+                </a:tc>
+                <a:tc>
+                  <a:txBody>
+                    <a:bodyPr/>
+                    <a:lstStyle/>
+                    <a:p>
+                      <a:pPr algn="r"/>
+                      <a:r>
+                        <a:rPr sz="1300" b="1" i="0">
+                          <a:solidFill>
+                            <a:srgbClr val="1A2332"/>
+                          </a:solidFill>
+                          <a:latin typeface="Calibri"/>
+                          <a:ea typeface="Calibri"/>
+                          <a:cs typeface="Calibri"/>
+                        </a:rPr>
+                        <a:t>договорная</a:t>
+                      </a:r>
+                    </a:p>
+                  </a:txBody>
+                  <a:tcPr anchor="ctr">
+                    <a:solidFill>
+                      <a:srgbClr val="FFFFFF"/>
+                    </a:solidFill>
+                  </a:tcPr>
+                </a:tc>
+              </a:tr>
+            </a:tbl>
+          </a:graphicData>
+        </a:graphic>
+      </p:graphicFrame>
+      <p:sp>
+        <p:nvSpPr>
+          <p:cNvPr id="11" name="Rounded Rectangle 10"/>
+          <p:cNvSpPr/>
+          <p:nvPr/>
+        </p:nvSpPr>
+        <p:spPr>
+          <a:xfrm>
+            <a:off x="7100640" y="1680000"/>
+            <a:ext cx="4557960" cy="3650000"/>
+          </a:xfrm>
+          <a:prstGeom prst="roundRect">
+            <a:avLst/>
+          </a:prstGeom>
+          <a:solidFill>
+            <a:srgbClr val="FFFFFF"/>
+          </a:solidFill>
+          <a:ln>
+            <a:noFill/>
+          </a:ln>
+          <a:effectLst/>
+        </p:spPr>
+        <p:style>
+          <a:lnRef idx="1">
+            <a:schemeClr val="accent1"/>
+          </a:lnRef>
+          <a:fillRef idx="3">
+            <a:schemeClr val="accent1"/>
+          </a:fillRef>
+          <a:effectRef idx="2">
+            <a:schemeClr val="accent1"/>
+          </a:effectRef>
+          <a:fontRef idx="minor">
+            <a:schemeClr val="lt1"/>
+          </a:fontRef>
+        </p:style>
+        <p:txBody>
+          <a:bodyPr rtlCol="0" anchor="ctr"/>
+          <a:lstStyle/>
+          <a:p>
+            <a:pPr algn="ctr"/>
+          </a:p>
+        </p:txBody>
+      </p:sp>
+      <p:sp>
+        <p:nvSpPr>
+          <p:cNvPr id="12" name="TextBox 11"/>
+          <p:cNvSpPr txBox="1"/>
+          <p:nvPr/>
+        </p:nvSpPr>
+        <p:spPr>
+          <a:xfrm>
+            <a:off x="7328040" y="1780000"/>
+            <a:ext cx="4102560" cy="380000"/>
+          </a:xfrm>
+          <a:prstGeom prst="rect">
+            <a:avLst/>
+          </a:prstGeom>
+          <a:noFill/>
+        </p:spPr>
+        <p:txBody>
+          <a:bodyPr wrap="square" anchor="t">
+            <a:spAutoFit/>
+          </a:bodyPr>
+          <a:lstStyle/>
+          <a:p>
+            <a:pPr algn="l"/>
+            <a:r>
+              <a:rPr sz="2000" b="1" i="0">
+                <a:solidFill>
+                  <a:srgbClr val="0B1F3A"/>
+                </a:solidFill>
+                <a:latin typeface="Calibri"/>
+                <a:ea typeface="Calibri"/>
+                <a:cs typeface="Calibri"/>
+              </a:rPr>
+              <a:t>Серверная версия</a:t>
+            </a:r>
+          </a:p>
+        </p:txBody>
+      </p:sp>
+      <p:sp>
+        <p:nvSpPr>
+          <p:cNvPr id="13" name="TextBox 12"/>
+          <p:cNvSpPr txBox="1"/>
+          <p:nvPr/>
+        </p:nvSpPr>
+        <p:spPr>
+          <a:xfrm>
+            <a:off x="7328040" y="2160000"/>
+            <a:ext cx="4102560" cy="420000"/>
+          </a:xfrm>
+          <a:prstGeom prst="rect">
+            <a:avLst/>
+          </a:prstGeom>
+          <a:noFill/>
+        </p:spPr>
+        <p:txBody>
+          <a:bodyPr wrap="square" anchor="t">
+            <a:spAutoFit/>
+          </a:bodyPr>
+          <a:lstStyle/>
+          <a:p>
+            <a:pPr algn="l"/>
+            <a:r>
+              <a:rPr sz="1400" b="0" i="0">
+                <a:solidFill>
+                  <a:srgbClr val="5B6778"/>
+                </a:solidFill>
+                <a:latin typeface="Calibri"/>
+                <a:ea typeface="Calibri"/>
+                <a:cs typeface="Calibri"/>
+              </a:rPr>
+              <a:t>Размещение на инфраструктуре заказчика</a:t>
+            </a:r>
+          </a:p>
+        </p:txBody>
+      </p:sp>
+      <p:sp>
+        <p:nvSpPr>
+          <p:cNvPr id="14" name="TextBox 13"/>
+          <p:cNvSpPr txBox="1"/>
+          <p:nvPr/>
+        </p:nvSpPr>
+        <p:spPr>
+          <a:xfrm>
+            <a:off x="7328040" y="2620000"/>
+            <a:ext cx="4102560" cy="2400000"/>
+          </a:xfrm>
+          <a:prstGeom prst="rect">
+            <a:avLst/>
+          </a:prstGeom>
+          <a:noFill/>
+        </p:spPr>
+        <p:txBody>
+          <a:bodyPr wrap="square">
+            <a:spAutoFit/>
+          </a:bodyPr>
+          <a:lstStyle/>
+          <a:p>
+            <a:pPr algn="l">
+              <a:spcAft>
+                <a:spcPts val="1400"/>
+              </a:spcAft>
+            </a:pPr>
+            <a:r>
+              <a:rPr sz="1500" b="0" i="0">
+                <a:solidFill>
+                  <a:srgbClr val="1A2332"/>
+                </a:solidFill>
+                <a:latin typeface="Calibri"/>
+                <a:ea typeface="Calibri"/>
+                <a:cs typeface="Calibri"/>
+              </a:rPr>
+              <a:t>•  Стоимость в этом предложении не оговаривается</a:t>
+            </a:r>
+          </a:p>
+          <a:p>
+            <a:pPr algn="l">
+              <a:spcAft>
+                <a:spcPts val="1400"/>
+              </a:spcAft>
+            </a:pPr>
+            <a:r>
+              <a:rPr sz="1500" b="0" i="0">
+                <a:solidFill>
+                  <a:srgbClr val="1A2332"/>
+                </a:solidFill>
+                <a:latin typeface="Calibri"/>
+                <a:ea typeface="Calibri"/>
+                <a:cs typeface="Calibri"/>
+              </a:rPr>
+              <a:t>•  Условия поставки и внедрения — отдельно</a:t>
+            </a:r>
+          </a:p>
+          <a:p>
+            <a:pPr algn="l">
+              <a:spcAft>
+                <a:spcPts val="1400"/>
+              </a:spcAft>
+            </a:pPr>
+            <a:r>
+              <a:rPr sz="1500" b="0" i="0">
+                <a:solidFill>
+                  <a:srgbClr val="1A2332"/>
+                </a:solidFill>
+                <a:latin typeface="Calibri"/>
+                <a:ea typeface="Calibri"/>
+                <a:cs typeface="Calibri"/>
+              </a:rPr>
+              <a:t>•  Контур, доступы и сопровождение — под вашу инфраструктуру</a:t>
+            </a:r>
+          </a:p>
+        </p:txBody>
+      </p:sp>
+      <p:sp>
+        <p:nvSpPr>
+          <p:cNvPr id="15" name="Rounded Rectangle 14"/>
+          <p:cNvSpPr/>
+          <p:nvPr/>
+        </p:nvSpPr>
+        <p:spPr>
+          <a:xfrm>
+            <a:off x="502920" y="5450000"/>
+            <a:ext cx="11155680" cy="980000"/>
+          </a:xfrm>
+          <a:prstGeom prst="roundRect">
+            <a:avLst/>
+          </a:prstGeom>
+          <a:solidFill>
+            <a:srgbClr val="FFFFFF"/>
+          </a:solidFill>
+          <a:ln>
+            <a:noFill/>
+          </a:ln>
+          <a:effectLst/>
+        </p:spPr>
+        <p:style>
+          <a:lnRef idx="1">
+            <a:schemeClr val="accent1"/>
+          </a:lnRef>
+          <a:fillRef idx="3">
+            <a:schemeClr val="accent1"/>
+          </a:fillRef>
+          <a:effectRef idx="2">
+            <a:schemeClr val="accent1"/>
+          </a:effectRef>
+          <a:fontRef idx="minor">
+            <a:schemeClr val="lt1"/>
+          </a:fontRef>
+        </p:style>
+        <p:txBody>
+          <a:bodyPr rtlCol="0" anchor="ctr"/>
+          <a:lstStyle/>
+          <a:p>
+            <a:pPr algn="ctr"/>
+          </a:p>
+        </p:txBody>
+      </p:sp>
+      <p:sp>
+        <p:nvSpPr>
+          <p:cNvPr id="16" name="TextBox 15"/>
+          <p:cNvSpPr txBox="1"/>
+          <p:nvPr/>
+        </p:nvSpPr>
+        <p:spPr>
+          <a:xfrm>
+            <a:off x="731520" y="5580000"/>
+            <a:ext cx="10700000" cy="720000"/>
+          </a:xfrm>
+          <a:prstGeom prst="rect">
+            <a:avLst/>
+          </a:prstGeom>
+          <a:noFill/>
+        </p:spPr>
+        <p:txBody>
+          <a:bodyPr wrap="square" anchor="t">
+            <a:spAutoFit/>
+          </a:bodyPr>
+          <a:lstStyle/>
+          <a:p>
+            <a:pPr algn="l"/>
+            <a:r>
+              <a:rPr sz="1500" b="0" i="0">
+                <a:solidFill>
+                  <a:srgbClr val="1A2332"/>
+                </a:solidFill>
+                <a:latin typeface="Calibri"/>
+                <a:ea typeface="Calibri"/>
+                <a:cs typeface="Calibri"/>
+              </a:rPr>
+              <a:t>Дополнительно могут быть включены услуги по разработке или адаптации контента под специфику компании. Стоимость определяется по техническому заданию.</a:t>
+            </a:r>
+          </a:p>
+        </p:txBody>
+      </p:sp>
+      <p:sp>
+        <p:nvSpPr>
+          <p:cNvPr id="17" name="TextBox 16"/>
+          <p:cNvSpPr txBox="1"/>
+          <p:nvPr/>
+        </p:nvSpPr>
+        <p:spPr>
+          <a:xfrm>
+            <a:off x="10424160" y="6565392"/>
+            <a:ext cx="1280160" cy="256032"/>
+          </a:xfrm>
+          <a:prstGeom prst="rect">
+            <a:avLst/>
+          </a:prstGeom>
+          <a:noFill/>
+        </p:spPr>
+        <p:txBody>
+          <a:bodyPr wrap="square" anchor="t">
+            <a:spAutoFit/>
+          </a:bodyPr>
+          <a:lstStyle/>
+          <a:p>
+            <a:pPr algn="r"/>
+            <a:r>
+              <a:rPr sz="1100" b="0" i="0">
+                <a:solidFill>
+                  <a:srgbClr val="9AA3B0"/>
+                </a:solidFill>
+                <a:latin typeface="Calibri"/>
+                <a:ea typeface="Calibri"/>
+                <a:cs typeface="Calibri"/>
+              </a:rPr>
+              <a:t>17  /  17</a:t>
+            </a:r>
+          </a:p>
+        </p:txBody>
+      </p:sp>
+    </p:spTree>
+  </p:cSld>
+  <p:clrMapOvr>
+    <a:masterClrMapping/>
+  </p:clrMapOvr>
+</p:sld>
+</file>
+
 <file path=ppt/slides/slide2.xml><?xml version="1.0" encoding="utf-8"?>
 <p:sld xmlns:a="http://schemas.openxmlformats.org/drawingml/2006/main" xmlns:r="http://schemas.openxmlformats.org/officeDocument/2006/relationships" xmlns:p="http://schemas.openxmlformats.org/presentationml/2006/main">
   <p:cSld>
@@ -11460,7 +12479,7 @@
                 <a:ea typeface="Calibri"/>
                 <a:cs typeface="Calibri"/>
               </a:rPr>
-              <a:t>2  /  16</a:t>
+              <a:t>2  /  17</a:t>
             </a:r>
           </a:p>
         </p:txBody>
@@ -12405,7 +13424,7 @@
                 <a:ea typeface="Calibri"/>
                 <a:cs typeface="Calibri"/>
               </a:rPr>
-              <a:t>3  /  16</a:t>
+              <a:t>3  /  17</a:t>
             </a:r>
           </a:p>
         </p:txBody>
@@ -13311,7 +14330,7 @@
                 <a:ea typeface="Calibri"/>
                 <a:cs typeface="Calibri"/>
               </a:rPr>
-              <a:t>4  /  16</a:t>
+              <a:t>4  /  17</a:t>
             </a:r>
           </a:p>
         </p:txBody>
@@ -13756,7 +14775,7 @@
                 <a:ea typeface="Calibri"/>
                 <a:cs typeface="Calibri"/>
               </a:rPr>
-              <a:t>5  /  16</a:t>
+              <a:t>5  /  17</a:t>
             </a:r>
           </a:p>
         </p:txBody>
@@ -15065,7 +16084,7 @@
                 <a:ea typeface="Calibri"/>
                 <a:cs typeface="Calibri"/>
               </a:rPr>
-              <a:t>6  /  16</a:t>
+              <a:t>6  /  17</a:t>
             </a:r>
           </a:p>
         </p:txBody>
@@ -16280,7 +17299,7 @@
                 <a:ea typeface="Calibri"/>
                 <a:cs typeface="Calibri"/>
               </a:rPr>
-              <a:t>7  /  16</a:t>
+              <a:t>7  /  17</a:t>
             </a:r>
           </a:p>
         </p:txBody>
@@ -17144,7 +18163,7 @@
                 <a:ea typeface="Calibri"/>
                 <a:cs typeface="Calibri"/>
               </a:rPr>
-              <a:t>8  /  16</a:t>
+              <a:t>8  /  17</a:t>
             </a:r>
           </a:p>
         </p:txBody>
@@ -18144,7 +19163,7 @@
                 <a:ea typeface="Calibri"/>
                 <a:cs typeface="Calibri"/>
               </a:rPr>
-              <a:t>9  /  16</a:t>
+              <a:t>9  /  17</a:t>
             </a:r>
           </a:p>
         </p:txBody>

</xml_diff>